<commit_message>
Day 1 morning accessible: convert 17 embedded OLE equations to real text
Also removes the duplicate 'complement' word-image on S35, now that the summary
block is transcribed inline.

Co-Authored-By: Claude Opus 4.8 <noreply@anthropic.com>
</commit_message>
<xml_diff>
--- a/Day1_Probability/FW536_Day1_Morning_intro to probability_accessible.pptx
+++ b/Day1_Probability/FW536_Day1_Morning_intro to probability_accessible.pptx
@@ -10382,201 +10382,6 @@
           </a:p>
         </p:txBody>
       </p:sp>
-      <p:graphicFrame>
-        <p:nvGraphicFramePr>
-          <p:cNvPr id="55299" name="Object 7"/>
-          <p:cNvGraphicFramePr>
-            <a:graphicFrameLocks noGrp="1" noChangeAspect="1"/>
-          </p:cNvGraphicFramePr>
-          <p:nvPr>
-            <p:ph sz="quarter" idx="2"/>
-          </p:nvPr>
-        </p:nvGraphicFramePr>
-        <p:xfrm>
-          <a:off x="4953000" y="2362200"/>
-          <a:ext cx="2185988" cy="565150"/>
-        </p:xfrm>
-        <a:graphic>
-          <a:graphicData uri="http://schemas.openxmlformats.org/presentationml/2006/ole">
-            <mc:AlternateContent xmlns:mc="http://schemas.openxmlformats.org/markup-compatibility/2006">
-              <mc:Choice xmlns:v="urn:schemas-microsoft-com:vml" Requires="v">
-                <p:oleObj name="Equation" r:id="rId3" imgW="787058" imgH="203112" progId="Equation.DSMT4">
-                  <p:embed/>
-                </p:oleObj>
-              </mc:Choice>
-              <mc:Fallback>
-                <p:oleObj name="Equation" r:id="rId3" imgW="787058" imgH="203112" progId="Equation.DSMT4">
-                  <p:embed/>
-                  <p:pic>
-                    <p:nvPicPr>
-                      <p:cNvPr id="0" name=""/>
-                      <p:cNvPicPr>
-                        <a:picLocks noChangeAspect="1" noChangeArrowheads="1"/>
-                      </p:cNvPicPr>
-                      <p:nvPr/>
-                    </p:nvPicPr>
-                    <p:blipFill>
-                      <a:blip r:embed="rId4">
-                        <a:extLst>
-                          <a:ext uri="{28A0092B-C50C-407E-A947-70E740481C1C}">
-                            <a14:useLocalDpi xmlns:a14="http://schemas.microsoft.com/office/drawing/2010/main" val="0"/>
-                          </a:ext>
-                        </a:extLst>
-                      </a:blip>
-                      <a:srcRect/>
-                      <a:stretch>
-                        <a:fillRect/>
-                      </a:stretch>
-                    </p:blipFill>
-                    <p:spPr bwMode="auto">
-                      <a:xfrm>
-                        <a:off x="4953000" y="2362200"/>
-                        <a:ext cx="2185988" cy="565150"/>
-                      </a:xfrm>
-                      <a:prstGeom prst="rect">
-                        <a:avLst/>
-                      </a:prstGeom>
-                      <a:noFill/>
-                      <a:ln>
-                        <a:noFill/>
-                      </a:ln>
-                      <a:effectLst/>
-                      <a:extLst>
-                        <a:ext uri="{909E8E84-426E-40DD-AFC4-6F175D3DCCD1}">
-                          <a14:hiddenFill xmlns:a14="http://schemas.microsoft.com/office/drawing/2010/main">
-                            <a:solidFill>
-                              <a:srgbClr val="FFFFFF"/>
-                            </a:solidFill>
-                          </a14:hiddenFill>
-                        </a:ext>
-                        <a:ext uri="{91240B29-F687-4F45-9708-019B960494DF}">
-                          <a14:hiddenLine xmlns:a14="http://schemas.microsoft.com/office/drawing/2010/main" w="9525">
-                            <a:solidFill>
-                              <a:srgbClr val="000000"/>
-                            </a:solidFill>
-                            <a:miter lim="800000"/>
-                            <a:headEnd/>
-                            <a:tailEnd/>
-                          </a14:hiddenLine>
-                        </a:ext>
-                        <a:ext uri="{AF507438-7753-43E0-B8FC-AC1667EBCBE1}">
-                          <a14:hiddenEffects xmlns:a14="http://schemas.microsoft.com/office/drawing/2010/main">
-                            <a:effectLst>
-                              <a:outerShdw dist="35921" dir="2700000" algn="ctr" rotWithShape="0">
-                                <a:srgbClr val="808080"/>
-                              </a:outerShdw>
-                            </a:effectLst>
-                          </a14:hiddenEffects>
-                        </a:ext>
-                      </a:extLst>
-                    </p:spPr>
-                  </p:pic>
-                </p:oleObj>
-              </mc:Fallback>
-            </mc:AlternateContent>
-          </a:graphicData>
-        </a:graphic>
-      </p:graphicFrame>
-      <p:graphicFrame>
-        <p:nvGraphicFramePr>
-          <p:cNvPr id="55300" name="Object 9"/>
-          <p:cNvGraphicFramePr>
-            <a:graphicFrameLocks noGrp="1" noChangeAspect="1"/>
-          </p:cNvGraphicFramePr>
-          <p:nvPr>
-            <p:ph sz="quarter" idx="3"/>
-            <p:extLst>
-              <p:ext uri="{D42A27DB-BD31-4B8C-83A1-F6EECF244321}">
-                <p14:modId xmlns:p14="http://schemas.microsoft.com/office/powerpoint/2010/main" val="3763483402"/>
-              </p:ext>
-            </p:extLst>
-          </p:nvPr>
-        </p:nvGraphicFramePr>
-        <p:xfrm>
-          <a:off x="4453759" y="4750676"/>
-          <a:ext cx="2971800" cy="573088"/>
-        </p:xfrm>
-        <a:graphic>
-          <a:graphicData uri="http://schemas.openxmlformats.org/presentationml/2006/ole">
-            <mc:AlternateContent xmlns:mc="http://schemas.openxmlformats.org/markup-compatibility/2006">
-              <mc:Choice xmlns:v="urn:schemas-microsoft-com:vml" Requires="v">
-                <p:oleObj name="Equation" r:id="rId5" imgW="1054100" imgH="203200" progId="Equation.DSMT4">
-                  <p:embed/>
-                </p:oleObj>
-              </mc:Choice>
-              <mc:Fallback>
-                <p:oleObj name="Equation" r:id="rId5" imgW="1054100" imgH="203200" progId="Equation.DSMT4">
-                  <p:embed/>
-                  <p:pic>
-                    <p:nvPicPr>
-                      <p:cNvPr id="0" name=""/>
-                      <p:cNvPicPr>
-                        <a:picLocks noChangeAspect="1" noChangeArrowheads="1"/>
-                      </p:cNvPicPr>
-                      <p:nvPr/>
-                    </p:nvPicPr>
-                    <p:blipFill>
-                      <a:blip r:embed="rId6">
-                        <a:extLst>
-                          <a:ext uri="{28A0092B-C50C-407E-A947-70E740481C1C}">
-                            <a14:useLocalDpi xmlns:a14="http://schemas.microsoft.com/office/drawing/2010/main" val="0"/>
-                          </a:ext>
-                        </a:extLst>
-                      </a:blip>
-                      <a:srcRect/>
-                      <a:stretch>
-                        <a:fillRect/>
-                      </a:stretch>
-                    </p:blipFill>
-                    <p:spPr bwMode="auto">
-                      <a:xfrm>
-                        <a:off x="4453759" y="4750676"/>
-                        <a:ext cx="2971800" cy="573088"/>
-                      </a:xfrm>
-                      <a:prstGeom prst="rect">
-                        <a:avLst/>
-                      </a:prstGeom>
-                      <a:noFill/>
-                      <a:ln>
-                        <a:noFill/>
-                      </a:ln>
-                      <a:effectLst/>
-                      <a:extLst>
-                        <a:ext uri="{909E8E84-426E-40DD-AFC4-6F175D3DCCD1}">
-                          <a14:hiddenFill xmlns:a14="http://schemas.microsoft.com/office/drawing/2010/main">
-                            <a:solidFill>
-                              <a:srgbClr val="FFFFFF"/>
-                            </a:solidFill>
-                          </a14:hiddenFill>
-                        </a:ext>
-                        <a:ext uri="{91240B29-F687-4F45-9708-019B960494DF}">
-                          <a14:hiddenLine xmlns:a14="http://schemas.microsoft.com/office/drawing/2010/main" w="9525">
-                            <a:solidFill>
-                              <a:srgbClr val="000000"/>
-                            </a:solidFill>
-                            <a:miter lim="800000"/>
-                            <a:headEnd/>
-                            <a:tailEnd/>
-                          </a14:hiddenLine>
-                        </a:ext>
-                        <a:ext uri="{AF507438-7753-43E0-B8FC-AC1667EBCBE1}">
-                          <a14:hiddenEffects xmlns:a14="http://schemas.microsoft.com/office/drawing/2010/main">
-                            <a:effectLst>
-                              <a:outerShdw dist="35921" dir="2700000" algn="ctr" rotWithShape="0">
-                                <a:srgbClr val="808080"/>
-                              </a:outerShdw>
-                            </a:effectLst>
-                          </a14:hiddenEffects>
-                        </a:ext>
-                      </a:extLst>
-                    </p:spPr>
-                  </p:pic>
-                </p:oleObj>
-              </mc:Fallback>
-            </mc:AlternateContent>
-          </a:graphicData>
-        </a:graphic>
-      </p:graphicFrame>
       <p:sp>
         <p:nvSpPr>
           <p:cNvPr id="55301" name="TextBox 1"/>
@@ -10801,6 +10606,68 @@
             <a:r>
               <a:rPr lang="en-US" altLang="en-US" sz="2400"/>
               <a:t>Why “1” here?</a:t>
+            </a:r>
+          </a:p>
+        </p:txBody>
+      </p:sp>
+      <p:sp>
+        <p:nvSpPr>
+          <p:cNvPr id="55302" name="TextBox 55301"/>
+          <p:cNvSpPr txBox="1"/>
+          <p:nvPr/>
+        </p:nvSpPr>
+        <p:spPr>
+          <a:xfrm>
+            <a:off x="4953000" y="2362200"/>
+            <a:ext cx="2185988" cy="565150"/>
+          </a:xfrm>
+          <a:prstGeom prst="rect">
+            <a:avLst/>
+          </a:prstGeom>
+          <a:noFill/>
+        </p:spPr>
+        <p:txBody>
+          <a:bodyPr wrap="square" anchor="ctr" lIns="0" rIns="0" tIns="0" bIns="0">
+            <a:spAutoFit/>
+          </a:bodyPr>
+          <a:lstStyle/>
+          <a:p>
+            <a:r>
+              <a:rPr sz="2500">
+                <a:latin typeface="Cambria"/>
+              </a:rPr>
+              <a:t>0 ≤ P(E) ≤ 1</a:t>
+            </a:r>
+          </a:p>
+        </p:txBody>
+      </p:sp>
+      <p:sp>
+        <p:nvSpPr>
+          <p:cNvPr id="55303" name="TextBox 55302"/>
+          <p:cNvSpPr txBox="1"/>
+          <p:nvPr/>
+        </p:nvSpPr>
+        <p:spPr>
+          <a:xfrm>
+            <a:off x="4453759" y="4750676"/>
+            <a:ext cx="2971800" cy="573088"/>
+          </a:xfrm>
+          <a:prstGeom prst="rect">
+            <a:avLst/>
+          </a:prstGeom>
+          <a:noFill/>
+        </p:spPr>
+        <p:txBody>
+          <a:bodyPr wrap="square" anchor="ctr" lIns="0" rIns="0" tIns="0" bIns="0">
+            <a:spAutoFit/>
+          </a:bodyPr>
+          <a:lstStyle/>
+          <a:p>
+            <a:r>
+              <a:rPr sz="2600">
+                <a:latin typeface="Cambria"/>
+              </a:rPr>
+              <a:t>P(E') = 1 − P(E)</a:t>
             </a:r>
           </a:p>
         </p:txBody>
@@ -25491,106 +25358,37 @@
           </a:p>
         </p:txBody>
       </p:sp>
-      <p:graphicFrame>
-        <p:nvGraphicFramePr>
-          <p:cNvPr id="69636" name="Object 5"/>
-          <p:cNvGraphicFramePr>
-            <a:graphicFrameLocks noGrp="1" noChangeAspect="1"/>
-          </p:cNvGraphicFramePr>
-          <p:nvPr>
-            <p:ph sz="half" idx="2"/>
-            <p:extLst>
-              <p:ext uri="{D42A27DB-BD31-4B8C-83A1-F6EECF244321}">
-                <p14:modId xmlns:p14="http://schemas.microsoft.com/office/powerpoint/2010/main" val="505766225"/>
-              </p:ext>
-            </p:extLst>
-          </p:nvPr>
-        </p:nvGraphicFramePr>
-        <p:xfrm>
-          <a:off x="2393950" y="4096924"/>
-          <a:ext cx="6172200" cy="498475"/>
-        </p:xfrm>
-        <a:graphic>
-          <a:graphicData uri="http://schemas.openxmlformats.org/presentationml/2006/ole">
-            <mc:AlternateContent xmlns:mc="http://schemas.openxmlformats.org/markup-compatibility/2006">
-              <mc:Choice xmlns:v="urn:schemas-microsoft-com:vml" Requires="v">
-                <p:oleObj name="Equation" r:id="rId3" imgW="2514600" imgH="203200" progId="Equation.DSMT4">
-                  <p:embed/>
-                </p:oleObj>
-              </mc:Choice>
-              <mc:Fallback>
-                <p:oleObj name="Equation" r:id="rId3" imgW="2514600" imgH="203200" progId="Equation.DSMT4">
-                  <p:embed/>
-                  <p:pic>
-                    <p:nvPicPr>
-                      <p:cNvPr id="0" name=""/>
-                      <p:cNvPicPr>
-                        <a:picLocks noChangeAspect="1" noChangeArrowheads="1"/>
-                      </p:cNvPicPr>
-                      <p:nvPr/>
-                    </p:nvPicPr>
-                    <p:blipFill>
-                      <a:blip r:embed="rId4">
-                        <a:extLst>
-                          <a:ext uri="{28A0092B-C50C-407E-A947-70E740481C1C}">
-                            <a14:useLocalDpi xmlns:a14="http://schemas.microsoft.com/office/drawing/2010/main" val="0"/>
-                          </a:ext>
-                        </a:extLst>
-                      </a:blip>
-                      <a:srcRect/>
-                      <a:stretch>
-                        <a:fillRect/>
-                      </a:stretch>
-                    </p:blipFill>
-                    <p:spPr bwMode="auto">
-                      <a:xfrm>
-                        <a:off x="2393950" y="4096924"/>
-                        <a:ext cx="6172200" cy="498475"/>
-                      </a:xfrm>
-                      <a:prstGeom prst="rect">
-                        <a:avLst/>
-                      </a:prstGeom>
-                      <a:noFill/>
-                      <a:ln>
-                        <a:noFill/>
-                      </a:ln>
-                      <a:effectLst/>
-                      <a:extLst>
-                        <a:ext uri="{909E8E84-426E-40DD-AFC4-6F175D3DCCD1}">
-                          <a14:hiddenFill xmlns:a14="http://schemas.microsoft.com/office/drawing/2010/main">
-                            <a:solidFill>
-                              <a:srgbClr val="FFFFFF"/>
-                            </a:solidFill>
-                          </a14:hiddenFill>
-                        </a:ext>
-                        <a:ext uri="{91240B29-F687-4F45-9708-019B960494DF}">
-                          <a14:hiddenLine xmlns:a14="http://schemas.microsoft.com/office/drawing/2010/main" w="9525">
-                            <a:solidFill>
-                              <a:srgbClr val="000000"/>
-                            </a:solidFill>
-                            <a:miter lim="800000"/>
-                            <a:headEnd/>
-                            <a:tailEnd/>
-                          </a14:hiddenLine>
-                        </a:ext>
-                        <a:ext uri="{AF507438-7753-43E0-B8FC-AC1667EBCBE1}">
-                          <a14:hiddenEffects xmlns:a14="http://schemas.microsoft.com/office/drawing/2010/main">
-                            <a:effectLst>
-                              <a:outerShdw dist="35921" dir="2700000" algn="ctr" rotWithShape="0">
-                                <a:srgbClr val="808080"/>
-                              </a:outerShdw>
-                            </a:effectLst>
-                          </a14:hiddenEffects>
-                        </a:ext>
-                      </a:extLst>
-                    </p:spPr>
-                  </p:pic>
-                </p:oleObj>
-              </mc:Fallback>
-            </mc:AlternateContent>
-          </a:graphicData>
-        </a:graphic>
-      </p:graphicFrame>
+      <p:sp>
+        <p:nvSpPr>
+          <p:cNvPr id="4100" name="TextBox 4099"/>
+          <p:cNvSpPr txBox="1"/>
+          <p:nvPr/>
+        </p:nvSpPr>
+        <p:spPr>
+          <a:xfrm>
+            <a:off x="2393950" y="4096924"/>
+            <a:ext cx="6172200" cy="498475"/>
+          </a:xfrm>
+          <a:prstGeom prst="rect">
+            <a:avLst/>
+          </a:prstGeom>
+          <a:noFill/>
+        </p:spPr>
+        <p:txBody>
+          <a:bodyPr wrap="square" anchor="ctr" lIns="0" rIns="0" tIns="0" bIns="0">
+            <a:spAutoFit/>
+          </a:bodyPr>
+          <a:lstStyle/>
+          <a:p>
+            <a:r>
+              <a:rPr sz="2200">
+                <a:latin typeface="Cambria"/>
+              </a:rPr>
+              <a:t>P(A) = P(A | B);        P(B) = P(B | A)</a:t>
+            </a:r>
+          </a:p>
+        </p:txBody>
+      </p:sp>
     </p:spTree>
     <p:extLst>
       <p:ext uri="{BB962C8B-B14F-4D97-AF65-F5344CB8AC3E}">
@@ -25761,206 +25559,68 @@
           </a:p>
         </p:txBody>
       </p:sp>
-      <p:graphicFrame>
-        <p:nvGraphicFramePr>
-          <p:cNvPr id="71683" name="Object 4"/>
-          <p:cNvGraphicFramePr>
-            <a:graphicFrameLocks noGrp="1" noChangeAspect="1"/>
-          </p:cNvGraphicFramePr>
-          <p:nvPr>
-            <p:ph sz="quarter" idx="2"/>
-            <p:extLst>
-              <p:ext uri="{D42A27DB-BD31-4B8C-83A1-F6EECF244321}">
-                <p14:modId xmlns:p14="http://schemas.microsoft.com/office/powerpoint/2010/main" val="1668018776"/>
-              </p:ext>
-            </p:extLst>
-          </p:nvPr>
-        </p:nvGraphicFramePr>
-        <p:xfrm>
-          <a:off x="2779713" y="2743995"/>
-          <a:ext cx="5943600" cy="495300"/>
-        </p:xfrm>
-        <a:graphic>
-          <a:graphicData uri="http://schemas.openxmlformats.org/presentationml/2006/ole">
-            <mc:AlternateContent xmlns:mc="http://schemas.openxmlformats.org/markup-compatibility/2006">
-              <mc:Choice xmlns:v="urn:schemas-microsoft-com:vml" Requires="v">
-                <p:oleObj name="Equation" r:id="rId3" imgW="2438400" imgH="203200" progId="Equation.DSMT4">
-                  <p:embed/>
-                </p:oleObj>
-              </mc:Choice>
-              <mc:Fallback>
-                <p:oleObj name="Equation" r:id="rId3" imgW="2438400" imgH="203200" progId="Equation.DSMT4">
-                  <p:embed/>
-                  <p:pic>
-                    <p:nvPicPr>
-                      <p:cNvPr id="0" name=""/>
-                      <p:cNvPicPr>
-                        <a:picLocks noChangeAspect="1" noChangeArrowheads="1"/>
-                      </p:cNvPicPr>
-                      <p:nvPr/>
-                    </p:nvPicPr>
-                    <p:blipFill>
-                      <a:blip r:embed="rId4">
-                        <a:extLst>
-                          <a:ext uri="{28A0092B-C50C-407E-A947-70E740481C1C}">
-                            <a14:useLocalDpi xmlns:a14="http://schemas.microsoft.com/office/drawing/2010/main" val="0"/>
-                          </a:ext>
-                        </a:extLst>
-                      </a:blip>
-                      <a:srcRect/>
-                      <a:stretch>
-                        <a:fillRect/>
-                      </a:stretch>
-                    </p:blipFill>
-                    <p:spPr bwMode="auto">
-                      <a:xfrm>
-                        <a:off x="2779713" y="2743995"/>
-                        <a:ext cx="5943600" cy="495300"/>
-                      </a:xfrm>
-                      <a:prstGeom prst="rect">
-                        <a:avLst/>
-                      </a:prstGeom>
-                      <a:noFill/>
-                      <a:ln>
-                        <a:noFill/>
-                      </a:ln>
-                      <a:effectLst/>
-                      <a:extLst>
-                        <a:ext uri="{909E8E84-426E-40DD-AFC4-6F175D3DCCD1}">
-                          <a14:hiddenFill xmlns:a14="http://schemas.microsoft.com/office/drawing/2010/main">
-                            <a:solidFill>
-                              <a:srgbClr val="FFFFFF"/>
-                            </a:solidFill>
-                          </a14:hiddenFill>
-                        </a:ext>
-                        <a:ext uri="{91240B29-F687-4F45-9708-019B960494DF}">
-                          <a14:hiddenLine xmlns:a14="http://schemas.microsoft.com/office/drawing/2010/main" w="9525">
-                            <a:solidFill>
-                              <a:srgbClr val="000000"/>
-                            </a:solidFill>
-                            <a:miter lim="800000"/>
-                            <a:headEnd/>
-                            <a:tailEnd/>
-                          </a14:hiddenLine>
-                        </a:ext>
-                        <a:ext uri="{AF507438-7753-43E0-B8FC-AC1667EBCBE1}">
-                          <a14:hiddenEffects xmlns:a14="http://schemas.microsoft.com/office/drawing/2010/main">
-                            <a:effectLst>
-                              <a:outerShdw dist="35921" dir="2700000" algn="ctr" rotWithShape="0">
-                                <a:srgbClr val="808080"/>
-                              </a:outerShdw>
-                            </a:effectLst>
-                          </a14:hiddenEffects>
-                        </a:ext>
-                      </a:extLst>
-                    </p:spPr>
-                  </p:pic>
-                </p:oleObj>
-              </mc:Fallback>
-            </mc:AlternateContent>
-          </a:graphicData>
-        </a:graphic>
-      </p:graphicFrame>
-      <p:graphicFrame>
-        <p:nvGraphicFramePr>
-          <p:cNvPr id="6149" name="Object 6"/>
-          <p:cNvGraphicFramePr>
-            <a:graphicFrameLocks noGrp="1" noChangeAspect="1"/>
-          </p:cNvGraphicFramePr>
-          <p:nvPr>
-            <p:ph sz="quarter" idx="3"/>
-            <p:extLst>
-              <p:ext uri="{D42A27DB-BD31-4B8C-83A1-F6EECF244321}">
-                <p14:modId xmlns:p14="http://schemas.microsoft.com/office/powerpoint/2010/main" val="2138061314"/>
-              </p:ext>
-            </p:extLst>
-          </p:nvPr>
-        </p:nvGraphicFramePr>
-        <p:xfrm>
-          <a:off x="4018756" y="4658158"/>
-          <a:ext cx="4154487" cy="554037"/>
-        </p:xfrm>
-        <a:graphic>
-          <a:graphicData uri="http://schemas.openxmlformats.org/presentationml/2006/ole">
-            <mc:AlternateContent xmlns:mc="http://schemas.openxmlformats.org/markup-compatibility/2006">
-              <mc:Choice xmlns:v="urn:schemas-microsoft-com:vml" Requires="v">
-                <p:oleObj name="Equation" r:id="rId5" imgW="1524000" imgH="203200" progId="Equation.DSMT4">
-                  <p:embed/>
-                </p:oleObj>
-              </mc:Choice>
-              <mc:Fallback>
-                <p:oleObj name="Equation" r:id="rId5" imgW="1524000" imgH="203200" progId="Equation.DSMT4">
-                  <p:embed/>
-                  <p:pic>
-                    <p:nvPicPr>
-                      <p:cNvPr id="0" name=""/>
-                      <p:cNvPicPr>
-                        <a:picLocks noChangeAspect="1" noChangeArrowheads="1"/>
-                      </p:cNvPicPr>
-                      <p:nvPr/>
-                    </p:nvPicPr>
-                    <p:blipFill>
-                      <a:blip r:embed="rId6">
-                        <a:extLst>
-                          <a:ext uri="{28A0092B-C50C-407E-A947-70E740481C1C}">
-                            <a14:useLocalDpi xmlns:a14="http://schemas.microsoft.com/office/drawing/2010/main" val="0"/>
-                          </a:ext>
-                        </a:extLst>
-                      </a:blip>
-                      <a:srcRect/>
-                      <a:stretch>
-                        <a:fillRect/>
-                      </a:stretch>
-                    </p:blipFill>
-                    <p:spPr bwMode="auto">
-                      <a:xfrm>
-                        <a:off x="4018756" y="4658158"/>
-                        <a:ext cx="4154487" cy="554037"/>
-                      </a:xfrm>
-                      <a:prstGeom prst="rect">
-                        <a:avLst/>
-                      </a:prstGeom>
-                      <a:noFill/>
-                      <a:ln>
-                        <a:noFill/>
-                      </a:ln>
-                      <a:effectLst/>
-                      <a:extLst>
-                        <a:ext uri="{909E8E84-426E-40DD-AFC4-6F175D3DCCD1}">
-                          <a14:hiddenFill xmlns:a14="http://schemas.microsoft.com/office/drawing/2010/main">
-                            <a:solidFill>
-                              <a:srgbClr val="FFFFFF"/>
-                            </a:solidFill>
-                          </a14:hiddenFill>
-                        </a:ext>
-                        <a:ext uri="{91240B29-F687-4F45-9708-019B960494DF}">
-                          <a14:hiddenLine xmlns:a14="http://schemas.microsoft.com/office/drawing/2010/main" w="9525">
-                            <a:solidFill>
-                              <a:srgbClr val="000000"/>
-                            </a:solidFill>
-                            <a:miter lim="800000"/>
-                            <a:headEnd/>
-                            <a:tailEnd/>
-                          </a14:hiddenLine>
-                        </a:ext>
-                        <a:ext uri="{AF507438-7753-43E0-B8FC-AC1667EBCBE1}">
-                          <a14:hiddenEffects xmlns:a14="http://schemas.microsoft.com/office/drawing/2010/main">
-                            <a:effectLst>
-                              <a:outerShdw dist="35921" dir="2700000" algn="ctr" rotWithShape="0">
-                                <a:srgbClr val="808080"/>
-                              </a:outerShdw>
-                            </a:effectLst>
-                          </a14:hiddenEffects>
-                        </a:ext>
-                      </a:extLst>
-                    </p:spPr>
-                  </p:pic>
-                </p:oleObj>
-              </mc:Fallback>
-            </mc:AlternateContent>
-          </a:graphicData>
-        </a:graphic>
-      </p:graphicFrame>
+      <p:sp>
+        <p:nvSpPr>
+          <p:cNvPr id="6150" name="TextBox 6149"/>
+          <p:cNvSpPr txBox="1"/>
+          <p:nvPr/>
+        </p:nvSpPr>
+        <p:spPr>
+          <a:xfrm>
+            <a:off x="2779713" y="2743995"/>
+            <a:ext cx="5943600" cy="495300"/>
+          </a:xfrm>
+          <a:prstGeom prst="rect">
+            <a:avLst/>
+          </a:prstGeom>
+          <a:noFill/>
+        </p:spPr>
+        <p:txBody>
+          <a:bodyPr wrap="square" anchor="ctr" lIns="0" rIns="0" tIns="0" bIns="0">
+            <a:spAutoFit/>
+          </a:bodyPr>
+          <a:lstStyle/>
+          <a:p>
+            <a:r>
+              <a:rPr sz="2100">
+                <a:latin typeface="Cambria"/>
+              </a:rPr>
+              <a:t>P(A and B) = P(A ∩ B) = P(A) · P(B | A)</a:t>
+            </a:r>
+          </a:p>
+        </p:txBody>
+      </p:sp>
+      <p:sp>
+        <p:nvSpPr>
+          <p:cNvPr id="6151" name="TextBox 6150"/>
+          <p:cNvSpPr txBox="1"/>
+          <p:nvPr/>
+        </p:nvSpPr>
+        <p:spPr>
+          <a:xfrm>
+            <a:off x="4018756" y="4658158"/>
+            <a:ext cx="4154487" cy="554037"/>
+          </a:xfrm>
+          <a:prstGeom prst="rect">
+            <a:avLst/>
+          </a:prstGeom>
+          <a:noFill/>
+        </p:spPr>
+        <p:txBody>
+          <a:bodyPr wrap="square" anchor="ctr" lIns="0" rIns="0" tIns="0" bIns="0">
+            <a:spAutoFit/>
+          </a:bodyPr>
+          <a:lstStyle/>
+          <a:p>
+            <a:r>
+              <a:rPr sz="2400">
+                <a:latin typeface="Cambria"/>
+              </a:rPr>
+              <a:t>P(A and B) = P(A) · P(B)</a:t>
+            </a:r>
+          </a:p>
+        </p:txBody>
+      </p:sp>
     </p:spTree>
     <p:extLst>
       <p:ext uri="{BB962C8B-B14F-4D97-AF65-F5344CB8AC3E}">
@@ -26190,106 +25850,6 @@
           </a:extLst>
         </p:spPr>
       </p:pic>
-      <p:graphicFrame>
-        <p:nvGraphicFramePr>
-          <p:cNvPr id="73732" name="Object 4"/>
-          <p:cNvGraphicFramePr>
-            <a:graphicFrameLocks noGrp="1" noChangeAspect="1"/>
-          </p:cNvGraphicFramePr>
-          <p:nvPr>
-            <p:ph sz="quarter" idx="2"/>
-            <p:extLst>
-              <p:ext uri="{D42A27DB-BD31-4B8C-83A1-F6EECF244321}">
-                <p14:modId xmlns:p14="http://schemas.microsoft.com/office/powerpoint/2010/main" val="2023378143"/>
-              </p:ext>
-            </p:extLst>
-          </p:nvPr>
-        </p:nvGraphicFramePr>
-        <p:xfrm>
-          <a:off x="3086100" y="5715000"/>
-          <a:ext cx="5943600" cy="495300"/>
-        </p:xfrm>
-        <a:graphic>
-          <a:graphicData uri="http://schemas.openxmlformats.org/presentationml/2006/ole">
-            <mc:AlternateContent xmlns:mc="http://schemas.openxmlformats.org/markup-compatibility/2006">
-              <mc:Choice xmlns:v="urn:schemas-microsoft-com:vml" Requires="v">
-                <p:oleObj name="Equation" r:id="rId5" imgW="2438400" imgH="203200" progId="Equation.DSMT4">
-                  <p:embed/>
-                </p:oleObj>
-              </mc:Choice>
-              <mc:Fallback>
-                <p:oleObj name="Equation" r:id="rId5" imgW="2438400" imgH="203200" progId="Equation.DSMT4">
-                  <p:embed/>
-                  <p:pic>
-                    <p:nvPicPr>
-                      <p:cNvPr id="0" name=""/>
-                      <p:cNvPicPr>
-                        <a:picLocks noChangeAspect="1" noChangeArrowheads="1"/>
-                      </p:cNvPicPr>
-                      <p:nvPr/>
-                    </p:nvPicPr>
-                    <p:blipFill>
-                      <a:blip r:embed="rId6">
-                        <a:extLst>
-                          <a:ext uri="{28A0092B-C50C-407E-A947-70E740481C1C}">
-                            <a14:useLocalDpi xmlns:a14="http://schemas.microsoft.com/office/drawing/2010/main" val="0"/>
-                          </a:ext>
-                        </a:extLst>
-                      </a:blip>
-                      <a:srcRect/>
-                      <a:stretch>
-                        <a:fillRect/>
-                      </a:stretch>
-                    </p:blipFill>
-                    <p:spPr bwMode="auto">
-                      <a:xfrm>
-                        <a:off x="3086100" y="5715000"/>
-                        <a:ext cx="5943600" cy="495300"/>
-                      </a:xfrm>
-                      <a:prstGeom prst="rect">
-                        <a:avLst/>
-                      </a:prstGeom>
-                      <a:noFill/>
-                      <a:ln>
-                        <a:noFill/>
-                      </a:ln>
-                      <a:effectLst/>
-                      <a:extLst>
-                        <a:ext uri="{909E8E84-426E-40DD-AFC4-6F175D3DCCD1}">
-                          <a14:hiddenFill xmlns:a14="http://schemas.microsoft.com/office/drawing/2010/main">
-                            <a:solidFill>
-                              <a:srgbClr val="FFFFFF"/>
-                            </a:solidFill>
-                          </a14:hiddenFill>
-                        </a:ext>
-                        <a:ext uri="{91240B29-F687-4F45-9708-019B960494DF}">
-                          <a14:hiddenLine xmlns:a14="http://schemas.microsoft.com/office/drawing/2010/main" w="9525">
-                            <a:solidFill>
-                              <a:srgbClr val="000000"/>
-                            </a:solidFill>
-                            <a:miter lim="800000"/>
-                            <a:headEnd/>
-                            <a:tailEnd/>
-                          </a14:hiddenLine>
-                        </a:ext>
-                        <a:ext uri="{AF507438-7753-43E0-B8FC-AC1667EBCBE1}">
-                          <a14:hiddenEffects xmlns:a14="http://schemas.microsoft.com/office/drawing/2010/main">
-                            <a:effectLst>
-                              <a:outerShdw dist="35921" dir="2700000" algn="ctr" rotWithShape="0">
-                                <a:srgbClr val="808080"/>
-                              </a:outerShdw>
-                            </a:effectLst>
-                          </a14:hiddenEffects>
-                        </a:ext>
-                      </a:extLst>
-                    </p:spPr>
-                  </p:pic>
-                </p:oleObj>
-              </mc:Fallback>
-            </mc:AlternateContent>
-          </a:graphicData>
-        </a:graphic>
-      </p:graphicFrame>
       <p:sp>
         <p:nvSpPr>
           <p:cNvPr id="73733" name="TextBox 1"/>
@@ -26467,6 +26027,37 @@
                 <a:latin typeface="Cambria"/>
               </a:rPr>
               <a:t>Pr{A, B} = (Area common to A and B) / (Area of S)</a:t>
+            </a:r>
+          </a:p>
+        </p:txBody>
+      </p:sp>
+      <p:sp>
+        <p:nvSpPr>
+          <p:cNvPr id="73735" name="TextBox 73734"/>
+          <p:cNvSpPr txBox="1"/>
+          <p:nvPr/>
+        </p:nvSpPr>
+        <p:spPr>
+          <a:xfrm>
+            <a:off x="3086100" y="5715000"/>
+            <a:ext cx="5943600" cy="495300"/>
+          </a:xfrm>
+          <a:prstGeom prst="rect">
+            <a:avLst/>
+          </a:prstGeom>
+          <a:noFill/>
+        </p:spPr>
+        <p:txBody>
+          <a:bodyPr wrap="square" anchor="ctr" lIns="0" rIns="0" tIns="0" bIns="0">
+            <a:spAutoFit/>
+          </a:bodyPr>
+          <a:lstStyle/>
+          <a:p>
+            <a:r>
+              <a:rPr sz="2100">
+                <a:latin typeface="Cambria"/>
+              </a:rPr>
+              <a:t>P(A and B) = P(A ∩ B) = P(A) · P(B | A)</a:t>
             </a:r>
           </a:p>
         </p:txBody>
@@ -27972,196 +27563,6 @@
           </a:p>
         </p:txBody>
       </p:sp>
-      <p:graphicFrame>
-        <p:nvGraphicFramePr>
-          <p:cNvPr id="75779" name="Object 4"/>
-          <p:cNvGraphicFramePr>
-            <a:graphicFrameLocks noGrp="1" noChangeAspect="1"/>
-          </p:cNvGraphicFramePr>
-          <p:nvPr>
-            <p:ph sz="quarter" idx="2"/>
-          </p:nvPr>
-        </p:nvGraphicFramePr>
-        <p:xfrm>
-          <a:off x="3019425" y="2857501"/>
-          <a:ext cx="6224588" cy="411163"/>
-        </p:xfrm>
-        <a:graphic>
-          <a:graphicData uri="http://schemas.openxmlformats.org/presentationml/2006/ole">
-            <mc:AlternateContent xmlns:mc="http://schemas.openxmlformats.org/markup-compatibility/2006">
-              <mc:Choice xmlns:v="urn:schemas-microsoft-com:vml" Requires="v">
-                <p:oleObj name="Equation" r:id="rId3" imgW="3073400" imgH="203200" progId="Equation.DSMT4">
-                  <p:embed/>
-                </p:oleObj>
-              </mc:Choice>
-              <mc:Fallback>
-                <p:oleObj name="Equation" r:id="rId3" imgW="3073400" imgH="203200" progId="Equation.DSMT4">
-                  <p:embed/>
-                  <p:pic>
-                    <p:nvPicPr>
-                      <p:cNvPr id="0" name=""/>
-                      <p:cNvPicPr>
-                        <a:picLocks noChangeAspect="1" noChangeArrowheads="1"/>
-                      </p:cNvPicPr>
-                      <p:nvPr/>
-                    </p:nvPicPr>
-                    <p:blipFill>
-                      <a:blip r:embed="rId4">
-                        <a:extLst>
-                          <a:ext uri="{28A0092B-C50C-407E-A947-70E740481C1C}">
-                            <a14:useLocalDpi xmlns:a14="http://schemas.microsoft.com/office/drawing/2010/main" val="0"/>
-                          </a:ext>
-                        </a:extLst>
-                      </a:blip>
-                      <a:srcRect/>
-                      <a:stretch>
-                        <a:fillRect/>
-                      </a:stretch>
-                    </p:blipFill>
-                    <p:spPr bwMode="auto">
-                      <a:xfrm>
-                        <a:off x="3019425" y="2857501"/>
-                        <a:ext cx="6224588" cy="411163"/>
-                      </a:xfrm>
-                      <a:prstGeom prst="rect">
-                        <a:avLst/>
-                      </a:prstGeom>
-                      <a:noFill/>
-                      <a:ln>
-                        <a:noFill/>
-                      </a:ln>
-                      <a:effectLst/>
-                      <a:extLst>
-                        <a:ext uri="{909E8E84-426E-40DD-AFC4-6F175D3DCCD1}">
-                          <a14:hiddenFill xmlns:a14="http://schemas.microsoft.com/office/drawing/2010/main">
-                            <a:solidFill>
-                              <a:srgbClr val="FFFFFF"/>
-                            </a:solidFill>
-                          </a14:hiddenFill>
-                        </a:ext>
-                        <a:ext uri="{91240B29-F687-4F45-9708-019B960494DF}">
-                          <a14:hiddenLine xmlns:a14="http://schemas.microsoft.com/office/drawing/2010/main" w="9525">
-                            <a:solidFill>
-                              <a:srgbClr val="000000"/>
-                            </a:solidFill>
-                            <a:miter lim="800000"/>
-                            <a:headEnd/>
-                            <a:tailEnd/>
-                          </a14:hiddenLine>
-                        </a:ext>
-                        <a:ext uri="{AF507438-7753-43E0-B8FC-AC1667EBCBE1}">
-                          <a14:hiddenEffects xmlns:a14="http://schemas.microsoft.com/office/drawing/2010/main">
-                            <a:effectLst>
-                              <a:outerShdw dist="35921" dir="2700000" algn="ctr" rotWithShape="0">
-                                <a:srgbClr val="808080"/>
-                              </a:outerShdw>
-                            </a:effectLst>
-                          </a14:hiddenEffects>
-                        </a:ext>
-                      </a:extLst>
-                    </p:spPr>
-                  </p:pic>
-                </p:oleObj>
-              </mc:Fallback>
-            </mc:AlternateContent>
-          </a:graphicData>
-        </a:graphic>
-      </p:graphicFrame>
-      <p:graphicFrame>
-        <p:nvGraphicFramePr>
-          <p:cNvPr id="75780" name="Object 6"/>
-          <p:cNvGraphicFramePr>
-            <a:graphicFrameLocks noGrp="1" noChangeAspect="1"/>
-          </p:cNvGraphicFramePr>
-          <p:nvPr>
-            <p:ph sz="quarter" idx="3"/>
-          </p:nvPr>
-        </p:nvGraphicFramePr>
-        <p:xfrm>
-          <a:off x="4695825" y="4551363"/>
-          <a:ext cx="2971800" cy="393700"/>
-        </p:xfrm>
-        <a:graphic>
-          <a:graphicData uri="http://schemas.openxmlformats.org/presentationml/2006/ole">
-            <mc:AlternateContent xmlns:mc="http://schemas.openxmlformats.org/markup-compatibility/2006">
-              <mc:Choice xmlns:v="urn:schemas-microsoft-com:vml" Requires="v">
-                <p:oleObj name="Equation" r:id="rId5" imgW="1536033" imgH="203112" progId="Equation.DSMT4">
-                  <p:embed/>
-                </p:oleObj>
-              </mc:Choice>
-              <mc:Fallback>
-                <p:oleObj name="Equation" r:id="rId5" imgW="1536033" imgH="203112" progId="Equation.DSMT4">
-                  <p:embed/>
-                  <p:pic>
-                    <p:nvPicPr>
-                      <p:cNvPr id="0" name=""/>
-                      <p:cNvPicPr>
-                        <a:picLocks noChangeAspect="1" noChangeArrowheads="1"/>
-                      </p:cNvPicPr>
-                      <p:nvPr/>
-                    </p:nvPicPr>
-                    <p:blipFill>
-                      <a:blip r:embed="rId6">
-                        <a:extLst>
-                          <a:ext uri="{28A0092B-C50C-407E-A947-70E740481C1C}">
-                            <a14:useLocalDpi xmlns:a14="http://schemas.microsoft.com/office/drawing/2010/main" val="0"/>
-                          </a:ext>
-                        </a:extLst>
-                      </a:blip>
-                      <a:srcRect/>
-                      <a:stretch>
-                        <a:fillRect/>
-                      </a:stretch>
-                    </p:blipFill>
-                    <p:spPr bwMode="auto">
-                      <a:xfrm>
-                        <a:off x="4695825" y="4551363"/>
-                        <a:ext cx="2971800" cy="393700"/>
-                      </a:xfrm>
-                      <a:prstGeom prst="rect">
-                        <a:avLst/>
-                      </a:prstGeom>
-                      <a:noFill/>
-                      <a:ln>
-                        <a:noFill/>
-                      </a:ln>
-                      <a:effectLst/>
-                      <a:extLst>
-                        <a:ext uri="{909E8E84-426E-40DD-AFC4-6F175D3DCCD1}">
-                          <a14:hiddenFill xmlns:a14="http://schemas.microsoft.com/office/drawing/2010/main">
-                            <a:solidFill>
-                              <a:srgbClr val="FFFFFF"/>
-                            </a:solidFill>
-                          </a14:hiddenFill>
-                        </a:ext>
-                        <a:ext uri="{91240B29-F687-4F45-9708-019B960494DF}">
-                          <a14:hiddenLine xmlns:a14="http://schemas.microsoft.com/office/drawing/2010/main" w="9525">
-                            <a:solidFill>
-                              <a:srgbClr val="000000"/>
-                            </a:solidFill>
-                            <a:miter lim="800000"/>
-                            <a:headEnd/>
-                            <a:tailEnd/>
-                          </a14:hiddenLine>
-                        </a:ext>
-                        <a:ext uri="{AF507438-7753-43E0-B8FC-AC1667EBCBE1}">
-                          <a14:hiddenEffects xmlns:a14="http://schemas.microsoft.com/office/drawing/2010/main">
-                            <a:effectLst>
-                              <a:outerShdw dist="35921" dir="2700000" algn="ctr" rotWithShape="0">
-                                <a:srgbClr val="808080"/>
-                              </a:outerShdw>
-                            </a:effectLst>
-                          </a14:hiddenEffects>
-                        </a:ext>
-                      </a:extLst>
-                    </p:spPr>
-                  </p:pic>
-                </p:oleObj>
-              </mc:Fallback>
-            </mc:AlternateContent>
-          </a:graphicData>
-        </a:graphic>
-      </p:graphicFrame>
       <p:sp>
         <p:nvSpPr>
           <p:cNvPr id="75781" name="TextBox 5"/>
@@ -28502,6 +27903,68 @@
           </a:extLst>
         </p:spPr>
       </p:cxnSp>
+      <p:sp>
+        <p:nvSpPr>
+          <p:cNvPr id="75784" name="TextBox 75783"/>
+          <p:cNvSpPr txBox="1"/>
+          <p:nvPr/>
+        </p:nvSpPr>
+        <p:spPr>
+          <a:xfrm>
+            <a:off x="3019425" y="2857501"/>
+            <a:ext cx="6224588" cy="411163"/>
+          </a:xfrm>
+          <a:prstGeom prst="rect">
+            <a:avLst/>
+          </a:prstGeom>
+          <a:noFill/>
+        </p:spPr>
+        <p:txBody>
+          <a:bodyPr wrap="square" anchor="ctr" lIns="0" rIns="0" tIns="0" bIns="0">
+            <a:spAutoFit/>
+          </a:bodyPr>
+          <a:lstStyle/>
+          <a:p>
+            <a:r>
+              <a:rPr sz="1800">
+                <a:latin typeface="Cambria"/>
+              </a:rPr>
+              <a:t>P(A or B) = P(A ∪ B) = P(A) + P(B) − P(A and B)</a:t>
+            </a:r>
+          </a:p>
+        </p:txBody>
+      </p:sp>
+      <p:sp>
+        <p:nvSpPr>
+          <p:cNvPr id="75785" name="TextBox 75784"/>
+          <p:cNvSpPr txBox="1"/>
+          <p:nvPr/>
+        </p:nvSpPr>
+        <p:spPr>
+          <a:xfrm>
+            <a:off x="4695825" y="4551363"/>
+            <a:ext cx="3235569" cy="393700"/>
+          </a:xfrm>
+          <a:prstGeom prst="rect">
+            <a:avLst/>
+          </a:prstGeom>
+          <a:noFill/>
+        </p:spPr>
+        <p:txBody>
+          <a:bodyPr wrap="square" anchor="ctr" lIns="0" rIns="0" tIns="0" bIns="0">
+            <a:spAutoFit/>
+          </a:bodyPr>
+          <a:lstStyle/>
+          <a:p>
+            <a:r>
+              <a:rPr sz="1900">
+                <a:latin typeface="Cambria"/>
+              </a:rPr>
+              <a:t>P(A or B) = P(A) + P(B)</a:t>
+            </a:r>
+          </a:p>
+        </p:txBody>
+      </p:sp>
     </p:spTree>
     <p:extLst>
       <p:ext uri="{BB962C8B-B14F-4D97-AF65-F5344CB8AC3E}">
@@ -28620,101 +28083,6 @@
           </a:p>
         </p:txBody>
       </p:sp>
-      <p:graphicFrame>
-        <p:nvGraphicFramePr>
-          <p:cNvPr id="77827" name="Object 4"/>
-          <p:cNvGraphicFramePr>
-            <a:graphicFrameLocks noGrp="1" noChangeAspect="1"/>
-          </p:cNvGraphicFramePr>
-          <p:nvPr>
-            <p:ph sz="quarter" idx="2"/>
-          </p:nvPr>
-        </p:nvGraphicFramePr>
-        <p:xfrm>
-          <a:off x="3324225" y="2400301"/>
-          <a:ext cx="6224588" cy="411163"/>
-        </p:xfrm>
-        <a:graphic>
-          <a:graphicData uri="http://schemas.openxmlformats.org/presentationml/2006/ole">
-            <mc:AlternateContent xmlns:mc="http://schemas.openxmlformats.org/markup-compatibility/2006">
-              <mc:Choice xmlns:v="urn:schemas-microsoft-com:vml" Requires="v">
-                <p:oleObj name="Equation" r:id="rId3" imgW="3073400" imgH="203200" progId="Equation.DSMT4">
-                  <p:embed/>
-                </p:oleObj>
-              </mc:Choice>
-              <mc:Fallback>
-                <p:oleObj name="Equation" r:id="rId3" imgW="3073400" imgH="203200" progId="Equation.DSMT4">
-                  <p:embed/>
-                  <p:pic>
-                    <p:nvPicPr>
-                      <p:cNvPr id="0" name=""/>
-                      <p:cNvPicPr>
-                        <a:picLocks noChangeAspect="1" noChangeArrowheads="1"/>
-                      </p:cNvPicPr>
-                      <p:nvPr/>
-                    </p:nvPicPr>
-                    <p:blipFill>
-                      <a:blip r:embed="rId4">
-                        <a:extLst>
-                          <a:ext uri="{28A0092B-C50C-407E-A947-70E740481C1C}">
-                            <a14:useLocalDpi xmlns:a14="http://schemas.microsoft.com/office/drawing/2010/main" val="0"/>
-                          </a:ext>
-                        </a:extLst>
-                      </a:blip>
-                      <a:srcRect/>
-                      <a:stretch>
-                        <a:fillRect/>
-                      </a:stretch>
-                    </p:blipFill>
-                    <p:spPr bwMode="auto">
-                      <a:xfrm>
-                        <a:off x="3324225" y="2400301"/>
-                        <a:ext cx="6224588" cy="411163"/>
-                      </a:xfrm>
-                      <a:prstGeom prst="rect">
-                        <a:avLst/>
-                      </a:prstGeom>
-                      <a:noFill/>
-                      <a:ln>
-                        <a:noFill/>
-                      </a:ln>
-                      <a:effectLst/>
-                      <a:extLst>
-                        <a:ext uri="{909E8E84-426E-40DD-AFC4-6F175D3DCCD1}">
-                          <a14:hiddenFill xmlns:a14="http://schemas.microsoft.com/office/drawing/2010/main">
-                            <a:solidFill>
-                              <a:srgbClr val="FFFFFF"/>
-                            </a:solidFill>
-                          </a14:hiddenFill>
-                        </a:ext>
-                        <a:ext uri="{91240B29-F687-4F45-9708-019B960494DF}">
-                          <a14:hiddenLine xmlns:a14="http://schemas.microsoft.com/office/drawing/2010/main" w="9525">
-                            <a:solidFill>
-                              <a:srgbClr val="000000"/>
-                            </a:solidFill>
-                            <a:miter lim="800000"/>
-                            <a:headEnd/>
-                            <a:tailEnd/>
-                          </a14:hiddenLine>
-                        </a:ext>
-                        <a:ext uri="{AF507438-7753-43E0-B8FC-AC1667EBCBE1}">
-                          <a14:hiddenEffects xmlns:a14="http://schemas.microsoft.com/office/drawing/2010/main">
-                            <a:effectLst>
-                              <a:outerShdw dist="35921" dir="2700000" algn="ctr" rotWithShape="0">
-                                <a:srgbClr val="808080"/>
-                              </a:outerShdw>
-                            </a:effectLst>
-                          </a14:hiddenEffects>
-                        </a:ext>
-                      </a:extLst>
-                    </p:spPr>
-                  </p:pic>
-                </p:oleObj>
-              </mc:Fallback>
-            </mc:AlternateContent>
-          </a:graphicData>
-        </a:graphic>
-      </p:graphicFrame>
       <p:pic>
         <p:nvPicPr>
           <p:cNvPr id="77828" name="Picture 1" descr="Diagram: sample space S with two overlapping events A and B, overlap shaded, illustrating why the overlap is subtracted in the additive (OR) rule to avoid double counting." title="Diagram: sample space S with two overlapping events A and B, overlap shaded, ill"/>
@@ -29041,6 +28409,37 @@
           </a:extLst>
         </p:spPr>
       </p:cxnSp>
+      <p:sp>
+        <p:nvSpPr>
+          <p:cNvPr id="77829" name="TextBox 77828"/>
+          <p:cNvSpPr txBox="1"/>
+          <p:nvPr/>
+        </p:nvSpPr>
+        <p:spPr>
+          <a:xfrm>
+            <a:off x="3324225" y="2400301"/>
+            <a:ext cx="6224588" cy="411163"/>
+          </a:xfrm>
+          <a:prstGeom prst="rect">
+            <a:avLst/>
+          </a:prstGeom>
+          <a:noFill/>
+        </p:spPr>
+        <p:txBody>
+          <a:bodyPr wrap="square" anchor="ctr" lIns="0" rIns="0" tIns="0" bIns="0">
+            <a:spAutoFit/>
+          </a:bodyPr>
+          <a:lstStyle/>
+          <a:p>
+            <a:r>
+              <a:rPr sz="1800">
+                <a:latin typeface="Cambria"/>
+              </a:rPr>
+              <a:t>P(A or B) = P(A ∪ B) = P(A) + P(B) − P(A and B)</a:t>
+            </a:r>
+          </a:p>
+        </p:txBody>
+      </p:sp>
     </p:spTree>
     <p:extLst>
       <p:ext uri="{BB962C8B-B14F-4D97-AF65-F5344CB8AC3E}">
@@ -36671,125 +36070,101 @@
           </a:p>
         </p:txBody>
       </p:sp>
-      <p:graphicFrame>
-        <p:nvGraphicFramePr>
-          <p:cNvPr id="81922" name="Object 4"/>
-          <p:cNvGraphicFramePr>
-            <a:graphicFrameLocks noGrp="1" noChangeAspect="1"/>
-          </p:cNvGraphicFramePr>
-          <p:nvPr>
-            <p:ph idx="1"/>
-          </p:nvPr>
-        </p:nvGraphicFramePr>
-        <p:xfrm>
-          <a:off x="1828800" y="1820863"/>
-          <a:ext cx="8686800" cy="3714750"/>
-        </p:xfrm>
-        <a:graphic>
-          <a:graphicData uri="http://schemas.openxmlformats.org/presentationml/2006/ole">
-            <mc:AlternateContent xmlns:mc="http://schemas.openxmlformats.org/markup-compatibility/2006">
-              <mc:Choice xmlns:v="urn:schemas-microsoft-com:vml" Requires="v">
-                <p:oleObj name="Equation" r:id="rId3" imgW="4749800" imgH="2032000" progId="Equation.DSMT4">
-                  <p:embed/>
-                </p:oleObj>
-              </mc:Choice>
-              <mc:Fallback>
-                <p:oleObj name="Equation" r:id="rId3" imgW="4749800" imgH="2032000" progId="Equation.DSMT4">
-                  <p:embed/>
-                  <p:pic>
-                    <p:nvPicPr>
-                      <p:cNvPr id="0" name=""/>
-                      <p:cNvPicPr>
-                        <a:picLocks noChangeAspect="1" noChangeArrowheads="1"/>
-                      </p:cNvPicPr>
-                      <p:nvPr/>
-                    </p:nvPicPr>
-                    <p:blipFill>
-                      <a:blip r:embed="rId4">
-                        <a:extLst>
-                          <a:ext uri="{28A0092B-C50C-407E-A947-70E740481C1C}">
-                            <a14:useLocalDpi xmlns:a14="http://schemas.microsoft.com/office/drawing/2010/main" val="0"/>
-                          </a:ext>
-                        </a:extLst>
-                      </a:blip>
-                      <a:srcRect/>
-                      <a:stretch>
-                        <a:fillRect/>
-                      </a:stretch>
-                    </p:blipFill>
-                    <p:spPr bwMode="auto">
-                      <a:xfrm>
-                        <a:off x="1828800" y="1820863"/>
-                        <a:ext cx="8686800" cy="3714750"/>
-                      </a:xfrm>
-                      <a:prstGeom prst="rect">
-                        <a:avLst/>
-                      </a:prstGeom>
-                      <a:noFill/>
-                      <a:ln>
-                        <a:noFill/>
-                      </a:ln>
-                      <a:effectLst/>
-                      <a:extLst>
-                        <a:ext uri="{909E8E84-426E-40DD-AFC4-6F175D3DCCD1}">
-                          <a14:hiddenFill xmlns:a14="http://schemas.microsoft.com/office/drawing/2010/main">
-                            <a:solidFill>
-                              <a:srgbClr val="FFFFFF"/>
-                            </a:solidFill>
-                          </a14:hiddenFill>
-                        </a:ext>
-                        <a:ext uri="{91240B29-F687-4F45-9708-019B960494DF}">
-                          <a14:hiddenLine xmlns:a14="http://schemas.microsoft.com/office/drawing/2010/main" w="9525">
-                            <a:solidFill>
-                              <a:srgbClr val="000000"/>
-                            </a:solidFill>
-                            <a:miter lim="800000"/>
-                            <a:headEnd/>
-                            <a:tailEnd/>
-                          </a14:hiddenLine>
-                        </a:ext>
-                        <a:ext uri="{AF507438-7753-43E0-B8FC-AC1667EBCBE1}">
-                          <a14:hiddenEffects xmlns:a14="http://schemas.microsoft.com/office/drawing/2010/main">
-                            <a:effectLst>
-                              <a:outerShdw dist="35921" dir="2700000" algn="ctr" rotWithShape="0">
-                                <a:srgbClr val="808080"/>
-                              </a:outerShdw>
-                            </a:effectLst>
-                          </a14:hiddenEffects>
-                        </a:ext>
-                      </a:extLst>
-                    </p:spPr>
-                  </p:pic>
-                </p:oleObj>
-              </mc:Fallback>
-            </mc:AlternateContent>
-          </a:graphicData>
-        </a:graphic>
-      </p:graphicFrame>
-      <p:pic>
-        <p:nvPicPr>
-          <p:cNvPr id="3" name="Picture 2" descr="The word 'complement' rendered as an image, labeling the complement rule in the review of probability concepts." title="The word 'complement' rendered as an image, labeling the complement rule in the "/>
-          <p:cNvPicPr>
-            <a:picLocks noChangeAspect="1"/>
-          </p:cNvPicPr>
+      <p:sp>
+        <p:nvSpPr>
+          <p:cNvPr id="11267" name="TextBox 11266"/>
+          <p:cNvSpPr txBox="1"/>
           <p:nvPr/>
-        </p:nvPicPr>
-        <p:blipFill>
-          <a:blip r:embed="rId5"/>
-          <a:stretch>
-            <a:fillRect/>
-          </a:stretch>
-        </p:blipFill>
+        </p:nvSpPr>
         <p:spPr>
           <a:xfrm>
-            <a:off x="5805066" y="2313263"/>
-            <a:ext cx="1318548" cy="261771"/>
+            <a:off x="1828800" y="1820863"/>
+            <a:ext cx="8686800" cy="3714750"/>
           </a:xfrm>
           <a:prstGeom prst="rect">
             <a:avLst/>
           </a:prstGeom>
+          <a:noFill/>
         </p:spPr>
-      </p:pic>
+        <p:txBody>
+          <a:bodyPr wrap="square" anchor="ctr" lIns="0" rIns="0" tIns="0" bIns="0">
+            <a:spAutoFit/>
+          </a:bodyPr>
+          <a:lstStyle/>
+          <a:p>
+            <a:r>
+              <a:rPr sz="1600">
+                <a:latin typeface="Cambria"/>
+              </a:rPr>
+              <a:t>P(A) : probability of event A</a:t>
+            </a:r>
+          </a:p>
+          <a:p>
+            <a:r>
+              <a:rPr sz="1600">
+                <a:latin typeface="Cambria"/>
+              </a:rPr>
+              <a:t>P(A') = 1 − P(A) : probability of the complement of the event A</a:t>
+            </a:r>
+          </a:p>
+          <a:p>
+            <a:r>
+              <a:rPr sz="1600">
+                <a:latin typeface="Cambria"/>
+              </a:rPr>
+              <a:t>P(A) = P(A and B) + P(A and B') : decomposition of the probability of event A</a:t>
+            </a:r>
+          </a:p>
+          <a:p>
+            <a:r>
+              <a:rPr sz="1600">
+                <a:latin typeface="Cambria"/>
+              </a:rPr>
+              <a:t>P(B | A) = P(A and B) / P(A) : conditional events</a:t>
+            </a:r>
+          </a:p>
+          <a:p>
+            <a:r>
+              <a:rPr sz="1600">
+                <a:latin typeface="Cambria"/>
+              </a:rPr>
+              <a:t>P(B | A) = P(B) : independent events</a:t>
+            </a:r>
+          </a:p>
+          <a:p>
+            <a:r>
+              <a:rPr sz="1600">
+                <a:latin typeface="Cambria"/>
+              </a:rPr>
+              <a:t>P(A and B) = P(B | A) · P(A) : multiplication rule</a:t>
+            </a:r>
+          </a:p>
+          <a:p>
+            <a:r>
+              <a:rPr sz="1600">
+                <a:latin typeface="Cambria"/>
+              </a:rPr>
+              <a:t>P(A and B) = P(A) · P(B) : independent events</a:t>
+            </a:r>
+          </a:p>
+          <a:p>
+            <a:r>
+              <a:rPr sz="1600">
+                <a:latin typeface="Cambria"/>
+              </a:rPr>
+              <a:t>P(A or B) = P(A) + P(B) − P(A ∩ B) : addition rule</a:t>
+            </a:r>
+          </a:p>
+          <a:p>
+            <a:r>
+              <a:rPr sz="1600">
+                <a:latin typeface="Cambria"/>
+              </a:rPr>
+              <a:t>P(A or B) = P(A) + P(B) : mutually exclusive events</a:t>
+            </a:r>
+          </a:p>
+        </p:txBody>
+      </p:sp>
     </p:spTree>
     <p:extLst>
       <p:ext uri="{BB962C8B-B14F-4D97-AF65-F5344CB8AC3E}">
@@ -38583,259 +37958,6 @@
           </a:p>
         </p:txBody>
       </p:sp>
-      <p:graphicFrame>
-        <p:nvGraphicFramePr>
-          <p:cNvPr id="122883" name="Object 4"/>
-          <p:cNvGraphicFramePr>
-            <a:graphicFrameLocks noGrp="1" noChangeAspect="1"/>
-          </p:cNvGraphicFramePr>
-          <p:nvPr>
-            <p:ph sz="quarter" idx="2"/>
-          </p:nvPr>
-        </p:nvGraphicFramePr>
-        <p:xfrm>
-          <a:off x="9015412" y="2115006"/>
-          <a:ext cx="1882775" cy="457200"/>
-        </p:xfrm>
-        <a:graphic>
-          <a:graphicData uri="http://schemas.openxmlformats.org/presentationml/2006/ole">
-            <mc:AlternateContent xmlns:mc="http://schemas.openxmlformats.org/markup-compatibility/2006">
-              <mc:Choice xmlns:v="urn:schemas-microsoft-com:vml" Requires="v">
-                <p:oleObj name="Equation" r:id="rId3" imgW="939754" imgH="228738" progId="">
-                  <p:embed/>
-                </p:oleObj>
-              </mc:Choice>
-              <mc:Fallback>
-                <p:oleObj name="Equation" r:id="rId3" imgW="939754" imgH="228738" progId="">
-                  <p:embed/>
-                  <p:pic>
-                    <p:nvPicPr>
-                      <p:cNvPr id="122883" name="Object 4"/>
-                      <p:cNvPicPr>
-                        <a:picLocks noGrp="1" noChangeAspect="1" noChangeArrowheads="1"/>
-                      </p:cNvPicPr>
-                      <p:nvPr/>
-                    </p:nvPicPr>
-                    <p:blipFill>
-                      <a:blip r:embed="rId4">
-                        <a:extLst>
-                          <a:ext uri="{28A0092B-C50C-407E-A947-70E740481C1C}">
-                            <a14:useLocalDpi xmlns:a14="http://schemas.microsoft.com/office/drawing/2010/main" val="0"/>
-                          </a:ext>
-                        </a:extLst>
-                      </a:blip>
-                      <a:srcRect/>
-                      <a:stretch>
-                        <a:fillRect/>
-                      </a:stretch>
-                    </p:blipFill>
-                    <p:spPr bwMode="auto">
-                      <a:xfrm>
-                        <a:off x="9015412" y="2115006"/>
-                        <a:ext cx="1882775" cy="457200"/>
-                      </a:xfrm>
-                      <a:prstGeom prst="rect">
-                        <a:avLst/>
-                      </a:prstGeom>
-                      <a:noFill/>
-                      <a:ln>
-                        <a:noFill/>
-                      </a:ln>
-                      <a:extLst>
-                        <a:ext uri="{909E8E84-426E-40DD-AFC4-6F175D3DCCD1}">
-                          <a14:hiddenFill xmlns:a14="http://schemas.microsoft.com/office/drawing/2010/main">
-                            <a:solidFill>
-                              <a:srgbClr val="FFFFFF"/>
-                            </a:solidFill>
-                          </a14:hiddenFill>
-                        </a:ext>
-                        <a:ext uri="{91240B29-F687-4F45-9708-019B960494DF}">
-                          <a14:hiddenLine xmlns:a14="http://schemas.microsoft.com/office/drawing/2010/main" w="9525">
-                            <a:solidFill>
-                              <a:schemeClr val="tx1"/>
-                            </a:solidFill>
-                            <a:miter lim="800000"/>
-                            <a:headEnd/>
-                            <a:tailEnd/>
-                          </a14:hiddenLine>
-                        </a:ext>
-                      </a:extLst>
-                    </p:spPr>
-                  </p:pic>
-                </p:oleObj>
-              </mc:Fallback>
-            </mc:AlternateContent>
-          </a:graphicData>
-        </a:graphic>
-      </p:graphicFrame>
-      <p:graphicFrame>
-        <p:nvGraphicFramePr>
-          <p:cNvPr id="122884" name="Object 6"/>
-          <p:cNvGraphicFramePr>
-            <a:graphicFrameLocks noGrp="1" noChangeAspect="1"/>
-          </p:cNvGraphicFramePr>
-          <p:nvPr>
-            <p:ph sz="quarter" idx="3"/>
-          </p:nvPr>
-        </p:nvGraphicFramePr>
-        <p:xfrm>
-          <a:off x="3237707" y="2973387"/>
-          <a:ext cx="2422525" cy="703263"/>
-        </p:xfrm>
-        <a:graphic>
-          <a:graphicData uri="http://schemas.openxmlformats.org/presentationml/2006/ole">
-            <mc:AlternateContent xmlns:mc="http://schemas.openxmlformats.org/markup-compatibility/2006">
-              <mc:Choice xmlns:v="urn:schemas-microsoft-com:vml" Requires="v">
-                <p:oleObj name="Equation" r:id="rId5" imgW="787078" imgH="228738" progId="">
-                  <p:embed/>
-                </p:oleObj>
-              </mc:Choice>
-              <mc:Fallback>
-                <p:oleObj name="Equation" r:id="rId5" imgW="787078" imgH="228738" progId="">
-                  <p:embed/>
-                  <p:pic>
-                    <p:nvPicPr>
-                      <p:cNvPr id="122884" name="Object 6"/>
-                      <p:cNvPicPr>
-                        <a:picLocks noGrp="1" noChangeAspect="1" noChangeArrowheads="1"/>
-                      </p:cNvPicPr>
-                      <p:nvPr/>
-                    </p:nvPicPr>
-                    <p:blipFill>
-                      <a:blip r:embed="rId6">
-                        <a:extLst>
-                          <a:ext uri="{28A0092B-C50C-407E-A947-70E740481C1C}">
-                            <a14:useLocalDpi xmlns:a14="http://schemas.microsoft.com/office/drawing/2010/main" val="0"/>
-                          </a:ext>
-                        </a:extLst>
-                      </a:blip>
-                      <a:srcRect/>
-                      <a:stretch>
-                        <a:fillRect/>
-                      </a:stretch>
-                    </p:blipFill>
-                    <p:spPr bwMode="auto">
-                      <a:xfrm>
-                        <a:off x="3237707" y="2973387"/>
-                        <a:ext cx="2422525" cy="703263"/>
-                      </a:xfrm>
-                      <a:prstGeom prst="rect">
-                        <a:avLst/>
-                      </a:prstGeom>
-                      <a:noFill/>
-                      <a:ln>
-                        <a:noFill/>
-                      </a:ln>
-                      <a:extLst>
-                        <a:ext uri="{909E8E84-426E-40DD-AFC4-6F175D3DCCD1}">
-                          <a14:hiddenFill xmlns:a14="http://schemas.microsoft.com/office/drawing/2010/main">
-                            <a:solidFill>
-                              <a:srgbClr val="FFFFFF"/>
-                            </a:solidFill>
-                          </a14:hiddenFill>
-                        </a:ext>
-                        <a:ext uri="{91240B29-F687-4F45-9708-019B960494DF}">
-                          <a14:hiddenLine xmlns:a14="http://schemas.microsoft.com/office/drawing/2010/main" w="9525">
-                            <a:solidFill>
-                              <a:schemeClr val="tx1"/>
-                            </a:solidFill>
-                            <a:miter lim="800000"/>
-                            <a:headEnd/>
-                            <a:tailEnd/>
-                          </a14:hiddenLine>
-                        </a:ext>
-                      </a:extLst>
-                    </p:spPr>
-                  </p:pic>
-                </p:oleObj>
-              </mc:Fallback>
-            </mc:AlternateContent>
-          </a:graphicData>
-        </a:graphic>
-      </p:graphicFrame>
-      <p:graphicFrame>
-        <p:nvGraphicFramePr>
-          <p:cNvPr id="122885" name="Object 8"/>
-          <p:cNvGraphicFramePr>
-            <a:graphicFrameLocks noChangeAspect="1"/>
-          </p:cNvGraphicFramePr>
-          <p:nvPr/>
-        </p:nvGraphicFramePr>
-        <p:xfrm>
-          <a:off x="4543426" y="4945064"/>
-          <a:ext cx="2286000" cy="1317625"/>
-        </p:xfrm>
-        <a:graphic>
-          <a:graphicData uri="http://schemas.openxmlformats.org/presentationml/2006/ole">
-            <mc:AlternateContent xmlns:mc="http://schemas.openxmlformats.org/markup-compatibility/2006">
-              <mc:Choice xmlns:v="urn:schemas-microsoft-com:vml" Requires="v">
-                <p:oleObj name="Equation" r:id="rId7" imgW="749047" imgH="431570" progId="">
-                  <p:embed/>
-                </p:oleObj>
-              </mc:Choice>
-              <mc:Fallback>
-                <p:oleObj name="Equation" r:id="rId7" imgW="749047" imgH="431570" progId="">
-                  <p:embed/>
-                  <p:pic>
-                    <p:nvPicPr>
-                      <p:cNvPr id="122885" name="Object 8"/>
-                      <p:cNvPicPr>
-                        <a:picLocks noChangeAspect="1" noChangeArrowheads="1"/>
-                      </p:cNvPicPr>
-                      <p:nvPr/>
-                    </p:nvPicPr>
-                    <p:blipFill>
-                      <a:blip r:embed="rId8">
-                        <a:extLst>
-                          <a:ext uri="{28A0092B-C50C-407E-A947-70E740481C1C}">
-                            <a14:useLocalDpi xmlns:a14="http://schemas.microsoft.com/office/drawing/2010/main" val="0"/>
-                          </a:ext>
-                        </a:extLst>
-                      </a:blip>
-                      <a:srcRect/>
-                      <a:stretch>
-                        <a:fillRect/>
-                      </a:stretch>
-                    </p:blipFill>
-                    <p:spPr bwMode="auto">
-                      <a:xfrm>
-                        <a:off x="4543426" y="4945064"/>
-                        <a:ext cx="2286000" cy="1317625"/>
-                      </a:xfrm>
-                      <a:prstGeom prst="rect">
-                        <a:avLst/>
-                      </a:prstGeom>
-                      <a:noFill/>
-                      <a:ln>
-                        <a:noFill/>
-                      </a:ln>
-                      <a:extLst>
-                        <a:ext uri="{909E8E84-426E-40DD-AFC4-6F175D3DCCD1}">
-                          <a14:hiddenFill xmlns:a14="http://schemas.microsoft.com/office/drawing/2010/main">
-                            <a:solidFill>
-                              <a:srgbClr val="FFFFFF"/>
-                            </a:solidFill>
-                          </a14:hiddenFill>
-                        </a:ext>
-                        <a:ext uri="{91240B29-F687-4F45-9708-019B960494DF}">
-                          <a14:hiddenLine xmlns:a14="http://schemas.microsoft.com/office/drawing/2010/main" w="9525">
-                            <a:solidFill>
-                              <a:srgbClr val="000000"/>
-                            </a:solidFill>
-                            <a:miter lim="800000"/>
-                            <a:headEnd/>
-                            <a:tailEnd/>
-                          </a14:hiddenLine>
-                        </a:ext>
-                      </a:extLst>
-                    </p:spPr>
-                  </p:pic>
-                </p:oleObj>
-              </mc:Fallback>
-            </mc:AlternateContent>
-          </a:graphicData>
-        </a:graphic>
-      </p:graphicFrame>
       <p:sp>
         <p:nvSpPr>
           <p:cNvPr id="122886" name="TextBox 6"/>
@@ -39470,6 +38592,153 @@
                 </a:solidFill>
               </a:rPr>
               <a:t>Lower summation limit</a:t>
+            </a:r>
+          </a:p>
+        </p:txBody>
+      </p:sp>
+      <p:sp>
+        <p:nvSpPr>
+          <p:cNvPr id="122888" name="TextBox 122887"/>
+          <p:cNvSpPr txBox="1"/>
+          <p:nvPr/>
+        </p:nvSpPr>
+        <p:spPr>
+          <a:xfrm>
+            <a:off x="9015412" y="2115006"/>
+            <a:ext cx="2532184" cy="457200"/>
+          </a:xfrm>
+          <a:prstGeom prst="rect">
+            <a:avLst/>
+          </a:prstGeom>
+          <a:noFill/>
+        </p:spPr>
+        <p:txBody>
+          <a:bodyPr wrap="square" anchor="ctr" lIns="0" rIns="0" tIns="0" bIns="0">
+            <a:spAutoFit/>
+          </a:bodyPr>
+          <a:lstStyle/>
+          <a:p>
+            <a:r>
+              <a:rPr sz="1900">
+                <a:latin typeface="Cambria"/>
+              </a:rPr>
+              <a:t>{x</a:t>
+            </a:r>
+            <a:r>
+              <a:rPr sz="1900" baseline="-25000">
+                <a:latin typeface="Cambria"/>
+              </a:rPr>
+              <a:t>i</a:t>
+            </a:r>
+            <a:r>
+              <a:rPr sz="1900">
+                <a:latin typeface="Cambria"/>
+              </a:rPr>
+              <a:t> : i = 1, …, N}</a:t>
+            </a:r>
+          </a:p>
+        </p:txBody>
+      </p:sp>
+      <p:sp>
+        <p:nvSpPr>
+          <p:cNvPr id="122889" name="TextBox 122888"/>
+          <p:cNvSpPr txBox="1"/>
+          <p:nvPr/>
+        </p:nvSpPr>
+        <p:spPr>
+          <a:xfrm>
+            <a:off x="3237707" y="2973387"/>
+            <a:ext cx="2422525" cy="703263"/>
+          </a:xfrm>
+          <a:prstGeom prst="rect">
+            <a:avLst/>
+          </a:prstGeom>
+          <a:noFill/>
+        </p:spPr>
+        <p:txBody>
+          <a:bodyPr wrap="square" anchor="ctr" lIns="0" rIns="0" tIns="0" bIns="0">
+            <a:spAutoFit/>
+          </a:bodyPr>
+          <a:lstStyle/>
+          <a:p>
+            <a:r>
+              <a:rPr sz="2600">
+                <a:latin typeface="Cambria"/>
+              </a:rPr>
+              <a:t>0 ≤ P(x</a:t>
+            </a:r>
+            <a:r>
+              <a:rPr sz="2600" baseline="-25000">
+                <a:latin typeface="Cambria"/>
+              </a:rPr>
+              <a:t>i</a:t>
+            </a:r>
+            <a:r>
+              <a:rPr sz="2600">
+                <a:latin typeface="Cambria"/>
+              </a:rPr>
+              <a:t>) ≤ 1</a:t>
+            </a:r>
+          </a:p>
+        </p:txBody>
+      </p:sp>
+      <p:sp>
+        <p:nvSpPr>
+          <p:cNvPr id="122890" name="TextBox 122889"/>
+          <p:cNvSpPr txBox="1"/>
+          <p:nvPr/>
+        </p:nvSpPr>
+        <p:spPr>
+          <a:xfrm>
+            <a:off x="4543426" y="4945064"/>
+            <a:ext cx="2286000" cy="1317625"/>
+          </a:xfrm>
+          <a:prstGeom prst="rect">
+            <a:avLst/>
+          </a:prstGeom>
+          <a:noFill/>
+        </p:spPr>
+        <p:txBody>
+          <a:bodyPr wrap="square" anchor="ctr" lIns="0" rIns="0" tIns="0" bIns="0">
+            <a:spAutoFit/>
+          </a:bodyPr>
+          <a:lstStyle/>
+          <a:p>
+            <a:r>
+              <a:rPr sz="2100">
+                <a:latin typeface="Cambria"/>
+              </a:rPr>
+              <a:t>Σ</a:t>
+            </a:r>
+            <a:r>
+              <a:rPr sz="2100" baseline="-25000">
+                <a:latin typeface="Cambria"/>
+              </a:rPr>
+              <a:t>i=1</a:t>
+            </a:r>
+            <a:r>
+              <a:rPr sz="2100" baseline="30000">
+                <a:latin typeface="Cambria"/>
+              </a:rPr>
+              <a:t>N</a:t>
+            </a:r>
+            <a:r>
+              <a:rPr sz="2100">
+                <a:latin typeface="Cambria"/>
+              </a:rPr>
+              <a:t> P(x</a:t>
+            </a:r>
+            <a:r>
+              <a:rPr sz="2100" baseline="-25000">
+                <a:latin typeface="Cambria"/>
+              </a:rPr>
+              <a:t>i</a:t>
+            </a:r>
+            <a:r>
+              <a:rPr sz="2100">
+                <a:latin typeface="Cambria"/>
+              </a:rPr>
+              <a:t>) = 1</a:t>
             </a:r>
           </a:p>
         </p:txBody>
@@ -40299,91 +39568,6 @@
           </a:p>
         </p:txBody>
       </p:sp>
-      <p:graphicFrame>
-        <p:nvGraphicFramePr>
-          <p:cNvPr id="129028" name="Object 5"/>
-          <p:cNvGraphicFramePr>
-            <a:graphicFrameLocks noGrp="1" noChangeAspect="1"/>
-          </p:cNvGraphicFramePr>
-          <p:nvPr>
-            <p:ph sz="half" idx="2"/>
-          </p:nvPr>
-        </p:nvGraphicFramePr>
-        <p:xfrm>
-          <a:off x="5105400" y="2971800"/>
-          <a:ext cx="2362200" cy="1085850"/>
-        </p:xfrm>
-        <a:graphic>
-          <a:graphicData uri="http://schemas.openxmlformats.org/presentationml/2006/ole">
-            <mc:AlternateContent xmlns:mc="http://schemas.openxmlformats.org/markup-compatibility/2006">
-              <mc:Choice xmlns:v="urn:schemas-microsoft-com:vml" Requires="v">
-                <p:oleObj name="Equation" r:id="rId3" imgW="939754" imgH="431570" progId="">
-                  <p:embed/>
-                </p:oleObj>
-              </mc:Choice>
-              <mc:Fallback>
-                <p:oleObj name="Equation" r:id="rId3" imgW="939754" imgH="431570" progId="">
-                  <p:embed/>
-                  <p:pic>
-                    <p:nvPicPr>
-                      <p:cNvPr id="129028" name="Object 5"/>
-                      <p:cNvPicPr>
-                        <a:picLocks noGrp="1" noChangeAspect="1" noChangeArrowheads="1"/>
-                      </p:cNvPicPr>
-                      <p:nvPr/>
-                    </p:nvPicPr>
-                    <p:blipFill>
-                      <a:blip r:embed="rId4">
-                        <a:extLst>
-                          <a:ext uri="{28A0092B-C50C-407E-A947-70E740481C1C}">
-                            <a14:useLocalDpi xmlns:a14="http://schemas.microsoft.com/office/drawing/2010/main" val="0"/>
-                          </a:ext>
-                        </a:extLst>
-                      </a:blip>
-                      <a:srcRect/>
-                      <a:stretch>
-                        <a:fillRect/>
-                      </a:stretch>
-                    </p:blipFill>
-                    <p:spPr bwMode="auto">
-                      <a:xfrm>
-                        <a:off x="5105400" y="2971800"/>
-                        <a:ext cx="2362200" cy="1085850"/>
-                      </a:xfrm>
-                      <a:prstGeom prst="rect">
-                        <a:avLst/>
-                      </a:prstGeom>
-                      <a:noFill/>
-                      <a:ln>
-                        <a:noFill/>
-                      </a:ln>
-                      <a:extLst>
-                        <a:ext uri="{909E8E84-426E-40DD-AFC4-6F175D3DCCD1}">
-                          <a14:hiddenFill xmlns:a14="http://schemas.microsoft.com/office/drawing/2010/main">
-                            <a:solidFill>
-                              <a:srgbClr val="FFFFFF"/>
-                            </a:solidFill>
-                          </a14:hiddenFill>
-                        </a:ext>
-                        <a:ext uri="{91240B29-F687-4F45-9708-019B960494DF}">
-                          <a14:hiddenLine xmlns:a14="http://schemas.microsoft.com/office/drawing/2010/main" w="9525">
-                            <a:solidFill>
-                              <a:schemeClr val="tx1"/>
-                            </a:solidFill>
-                            <a:miter lim="800000"/>
-                            <a:headEnd/>
-                            <a:tailEnd/>
-                          </a14:hiddenLine>
-                        </a:ext>
-                      </a:extLst>
-                    </p:spPr>
-                  </p:pic>
-                </p:oleObj>
-              </mc:Fallback>
-            </mc:AlternateContent>
-          </a:graphicData>
-        </a:graphic>
-      </p:graphicFrame>
       <p:sp>
         <p:nvSpPr>
           <p:cNvPr id="129029" name="TextBox 5"/>
@@ -42212,6 +41396,79 @@
             <a:r>
               <a:rPr lang="en-US" altLang="en-US" sz="2400"/>
               <a:t>This is just a weighted average!</a:t>
+            </a:r>
+          </a:p>
+        </p:txBody>
+      </p:sp>
+      <p:sp>
+        <p:nvSpPr>
+          <p:cNvPr id="129037" name="TextBox 129036"/>
+          <p:cNvSpPr txBox="1"/>
+          <p:nvPr/>
+        </p:nvSpPr>
+        <p:spPr>
+          <a:xfrm>
+            <a:off x="5105400" y="2971800"/>
+            <a:ext cx="2362200" cy="1085850"/>
+          </a:xfrm>
+          <a:prstGeom prst="rect">
+            <a:avLst/>
+          </a:prstGeom>
+          <a:noFill/>
+        </p:spPr>
+        <p:txBody>
+          <a:bodyPr wrap="square" anchor="ctr" lIns="0" rIns="0" tIns="0" bIns="0">
+            <a:spAutoFit/>
+          </a:bodyPr>
+          <a:lstStyle/>
+          <a:p>
+            <a:r>
+              <a:rPr sz="1800">
+                <a:latin typeface="Cambria"/>
+              </a:rPr>
+              <a:t>μ = Σ</a:t>
+            </a:r>
+            <a:r>
+              <a:rPr sz="1800" baseline="-25000">
+                <a:latin typeface="Cambria"/>
+              </a:rPr>
+              <a:t>i=1</a:t>
+            </a:r>
+            <a:r>
+              <a:rPr sz="1800" baseline="30000">
+                <a:latin typeface="Cambria"/>
+              </a:rPr>
+              <a:t>N</a:t>
+            </a:r>
+            <a:r>
+              <a:rPr sz="1800">
+                <a:latin typeface="Cambria"/>
+              </a:rPr>
+              <a:t> x</a:t>
+            </a:r>
+            <a:r>
+              <a:rPr sz="1800" baseline="-25000">
+                <a:latin typeface="Cambria"/>
+              </a:rPr>
+              <a:t>i</a:t>
+            </a:r>
+            <a:r>
+              <a:rPr sz="1800">
+                <a:latin typeface="Cambria"/>
+              </a:rPr>
+              <a:t> P(x</a:t>
+            </a:r>
+            <a:r>
+              <a:rPr sz="1800" baseline="-25000">
+                <a:latin typeface="Cambria"/>
+              </a:rPr>
+              <a:t>i</a:t>
+            </a:r>
+            <a:r>
+              <a:rPr sz="1800">
+                <a:latin typeface="Cambria"/>
+              </a:rPr>
+              <a:t>)</a:t>
             </a:r>
           </a:p>
         </p:txBody>
@@ -42692,91 +41949,6 @@
           </a:p>
         </p:txBody>
       </p:sp>
-      <p:graphicFrame>
-        <p:nvGraphicFramePr>
-          <p:cNvPr id="131076" name="Object 5"/>
-          <p:cNvGraphicFramePr>
-            <a:graphicFrameLocks noGrp="1" noChangeAspect="1"/>
-          </p:cNvGraphicFramePr>
-          <p:nvPr>
-            <p:ph sz="half" idx="2"/>
-          </p:nvPr>
-        </p:nvGraphicFramePr>
-        <p:xfrm>
-          <a:off x="3802063" y="2617391"/>
-          <a:ext cx="3865562" cy="1095375"/>
-        </p:xfrm>
-        <a:graphic>
-          <a:graphicData uri="http://schemas.openxmlformats.org/presentationml/2006/ole">
-            <mc:AlternateContent xmlns:mc="http://schemas.openxmlformats.org/markup-compatibility/2006">
-              <mc:Choice xmlns:v="urn:schemas-microsoft-com:vml" Requires="v">
-                <p:oleObj name="Equation" r:id="rId3" imgW="1524368" imgH="431831" progId="">
-                  <p:embed/>
-                </p:oleObj>
-              </mc:Choice>
-              <mc:Fallback>
-                <p:oleObj name="Equation" r:id="rId3" imgW="1524368" imgH="431831" progId="">
-                  <p:embed/>
-                  <p:pic>
-                    <p:nvPicPr>
-                      <p:cNvPr id="131076" name="Object 5"/>
-                      <p:cNvPicPr>
-                        <a:picLocks noGrp="1" noChangeAspect="1" noChangeArrowheads="1"/>
-                      </p:cNvPicPr>
-                      <p:nvPr/>
-                    </p:nvPicPr>
-                    <p:blipFill>
-                      <a:blip r:embed="rId4">
-                        <a:extLst>
-                          <a:ext uri="{28A0092B-C50C-407E-A947-70E740481C1C}">
-                            <a14:useLocalDpi xmlns:a14="http://schemas.microsoft.com/office/drawing/2010/main" val="0"/>
-                          </a:ext>
-                        </a:extLst>
-                      </a:blip>
-                      <a:srcRect/>
-                      <a:stretch>
-                        <a:fillRect/>
-                      </a:stretch>
-                    </p:blipFill>
-                    <p:spPr bwMode="auto">
-                      <a:xfrm>
-                        <a:off x="3802063" y="2617391"/>
-                        <a:ext cx="3865562" cy="1095375"/>
-                      </a:xfrm>
-                      <a:prstGeom prst="rect">
-                        <a:avLst/>
-                      </a:prstGeom>
-                      <a:noFill/>
-                      <a:ln>
-                        <a:noFill/>
-                      </a:ln>
-                      <a:extLst>
-                        <a:ext uri="{909E8E84-426E-40DD-AFC4-6F175D3DCCD1}">
-                          <a14:hiddenFill xmlns:a14="http://schemas.microsoft.com/office/drawing/2010/main">
-                            <a:solidFill>
-                              <a:srgbClr val="FFFFFF"/>
-                            </a:solidFill>
-                          </a14:hiddenFill>
-                        </a:ext>
-                        <a:ext uri="{91240B29-F687-4F45-9708-019B960494DF}">
-                          <a14:hiddenLine xmlns:a14="http://schemas.microsoft.com/office/drawing/2010/main" w="9525">
-                            <a:solidFill>
-                              <a:schemeClr val="tx1"/>
-                            </a:solidFill>
-                            <a:miter lim="800000"/>
-                            <a:headEnd/>
-                            <a:tailEnd/>
-                          </a14:hiddenLine>
-                        </a:ext>
-                      </a:extLst>
-                    </p:spPr>
-                  </p:pic>
-                </p:oleObj>
-              </mc:Fallback>
-            </mc:AlternateContent>
-          </a:graphicData>
-        </a:graphic>
-      </p:graphicFrame>
       <p:sp>
         <p:nvSpPr>
           <p:cNvPr id="131077" name="TextBox 1"/>
@@ -43001,6 +42173,91 @@
             <a:r>
               <a:rPr lang="en-US" altLang="en-US" sz="2400"/>
               <a:t>This is just a weighted average!</a:t>
+            </a:r>
+          </a:p>
+        </p:txBody>
+      </p:sp>
+      <p:sp>
+        <p:nvSpPr>
+          <p:cNvPr id="131078" name="TextBox 131077"/>
+          <p:cNvSpPr txBox="1"/>
+          <p:nvPr/>
+        </p:nvSpPr>
+        <p:spPr>
+          <a:xfrm>
+            <a:off x="3802063" y="2617391"/>
+            <a:ext cx="3865562" cy="1095375"/>
+          </a:xfrm>
+          <a:prstGeom prst="rect">
+            <a:avLst/>
+          </a:prstGeom>
+          <a:noFill/>
+        </p:spPr>
+        <p:txBody>
+          <a:bodyPr wrap="square" anchor="ctr" lIns="0" rIns="0" tIns="0" bIns="0">
+            <a:spAutoFit/>
+          </a:bodyPr>
+          <a:lstStyle/>
+          <a:p>
+            <a:r>
+              <a:rPr sz="2100">
+                <a:latin typeface="Cambria"/>
+              </a:rPr>
+              <a:t>E(X) = μ</a:t>
+            </a:r>
+            <a:r>
+              <a:rPr sz="2100" baseline="-25000">
+                <a:latin typeface="Cambria"/>
+              </a:rPr>
+              <a:t>X</a:t>
+            </a:r>
+            <a:r>
+              <a:rPr sz="2100">
+                <a:latin typeface="Cambria"/>
+              </a:rPr>
+              <a:t> = Σ</a:t>
+            </a:r>
+            <a:r>
+              <a:rPr sz="2100" baseline="-25000">
+                <a:latin typeface="Cambria"/>
+              </a:rPr>
+              <a:t>i=1</a:t>
+            </a:r>
+            <a:r>
+              <a:rPr sz="2100" baseline="30000">
+                <a:latin typeface="Cambria"/>
+              </a:rPr>
+              <a:t>N</a:t>
+            </a:r>
+            <a:r>
+              <a:rPr sz="2100">
+                <a:latin typeface="Cambria"/>
+              </a:rPr>
+              <a:t> x</a:t>
+            </a:r>
+            <a:r>
+              <a:rPr sz="2100" baseline="-25000">
+                <a:latin typeface="Cambria"/>
+              </a:rPr>
+              <a:t>i</a:t>
+            </a:r>
+            <a:r>
+              <a:rPr sz="2100">
+                <a:latin typeface="Cambria"/>
+              </a:rPr>
+              <a:t> P(x</a:t>
+            </a:r>
+            <a:r>
+              <a:rPr sz="2100" baseline="-25000">
+                <a:latin typeface="Cambria"/>
+              </a:rPr>
+              <a:t>i</a:t>
+            </a:r>
+            <a:r>
+              <a:rPr sz="2100">
+                <a:latin typeface="Cambria"/>
+              </a:rPr>
+              <a:t>)</a:t>
             </a:r>
           </a:p>
         </p:txBody>
@@ -43202,91 +42459,6 @@
           </a:p>
         </p:txBody>
       </p:sp>
-      <p:graphicFrame>
-        <p:nvGraphicFramePr>
-          <p:cNvPr id="133123" name="Object 4"/>
-          <p:cNvGraphicFramePr>
-            <a:graphicFrameLocks noGrp="1" noChangeAspect="1"/>
-          </p:cNvGraphicFramePr>
-          <p:nvPr>
-            <p:ph sz="quarter" idx="2"/>
-          </p:nvPr>
-        </p:nvGraphicFramePr>
-        <p:xfrm>
-          <a:off x="4881076" y="2434774"/>
-          <a:ext cx="2855913" cy="882650"/>
-        </p:xfrm>
-        <a:graphic>
-          <a:graphicData uri="http://schemas.openxmlformats.org/presentationml/2006/ole">
-            <mc:AlternateContent xmlns:mc="http://schemas.openxmlformats.org/markup-compatibility/2006">
-              <mc:Choice xmlns:v="urn:schemas-microsoft-com:vml" Requires="v">
-                <p:oleObj name="Equation" r:id="rId3" imgW="1396678" imgH="431570" progId="">
-                  <p:embed/>
-                </p:oleObj>
-              </mc:Choice>
-              <mc:Fallback>
-                <p:oleObj name="Equation" r:id="rId3" imgW="1396678" imgH="431570" progId="">
-                  <p:embed/>
-                  <p:pic>
-                    <p:nvPicPr>
-                      <p:cNvPr id="133123" name="Object 4"/>
-                      <p:cNvPicPr>
-                        <a:picLocks noGrp="1" noChangeAspect="1" noChangeArrowheads="1"/>
-                      </p:cNvPicPr>
-                      <p:nvPr/>
-                    </p:nvPicPr>
-                    <p:blipFill>
-                      <a:blip r:embed="rId4">
-                        <a:extLst>
-                          <a:ext uri="{28A0092B-C50C-407E-A947-70E740481C1C}">
-                            <a14:useLocalDpi xmlns:a14="http://schemas.microsoft.com/office/drawing/2010/main" val="0"/>
-                          </a:ext>
-                        </a:extLst>
-                      </a:blip>
-                      <a:srcRect/>
-                      <a:stretch>
-                        <a:fillRect/>
-                      </a:stretch>
-                    </p:blipFill>
-                    <p:spPr bwMode="auto">
-                      <a:xfrm>
-                        <a:off x="4881076" y="2434774"/>
-                        <a:ext cx="2855913" cy="882650"/>
-                      </a:xfrm>
-                      <a:prstGeom prst="rect">
-                        <a:avLst/>
-                      </a:prstGeom>
-                      <a:noFill/>
-                      <a:ln>
-                        <a:noFill/>
-                      </a:ln>
-                      <a:extLst>
-                        <a:ext uri="{909E8E84-426E-40DD-AFC4-6F175D3DCCD1}">
-                          <a14:hiddenFill xmlns:a14="http://schemas.microsoft.com/office/drawing/2010/main">
-                            <a:solidFill>
-                              <a:srgbClr val="FFFFFF"/>
-                            </a:solidFill>
-                          </a14:hiddenFill>
-                        </a:ext>
-                        <a:ext uri="{91240B29-F687-4F45-9708-019B960494DF}">
-                          <a14:hiddenLine xmlns:a14="http://schemas.microsoft.com/office/drawing/2010/main" w="9525">
-                            <a:solidFill>
-                              <a:schemeClr val="tx1"/>
-                            </a:solidFill>
-                            <a:miter lim="800000"/>
-                            <a:headEnd/>
-                            <a:tailEnd/>
-                          </a14:hiddenLine>
-                        </a:ext>
-                      </a:extLst>
-                    </p:spPr>
-                  </p:pic>
-                </p:oleObj>
-              </mc:Fallback>
-            </mc:AlternateContent>
-          </a:graphicData>
-        </a:graphic>
-      </p:graphicFrame>
       <p:sp>
         <p:nvSpPr>
           <p:cNvPr id="133125" name="Rectangle 1"/>
@@ -43548,91 +42720,6 @@
           </a:p>
         </p:txBody>
       </p:sp>
-      <p:graphicFrame>
-        <p:nvGraphicFramePr>
-          <p:cNvPr id="8" name="Object 5"/>
-          <p:cNvGraphicFramePr>
-            <a:graphicFrameLocks noGrp="1" noChangeAspect="1"/>
-          </p:cNvGraphicFramePr>
-          <p:nvPr>
-            <p:ph sz="half" idx="2"/>
-          </p:nvPr>
-        </p:nvGraphicFramePr>
-        <p:xfrm>
-          <a:off x="4985267" y="5561043"/>
-          <a:ext cx="3865562" cy="1095375"/>
-        </p:xfrm>
-        <a:graphic>
-          <a:graphicData uri="http://schemas.openxmlformats.org/presentationml/2006/ole">
-            <mc:AlternateContent xmlns:mc="http://schemas.openxmlformats.org/markup-compatibility/2006">
-              <mc:Choice xmlns:v="urn:schemas-microsoft-com:vml" Requires="v">
-                <p:oleObj name="Equation" r:id="rId5" imgW="1524368" imgH="431831" progId="">
-                  <p:embed/>
-                </p:oleObj>
-              </mc:Choice>
-              <mc:Fallback>
-                <p:oleObj name="Equation" r:id="rId5" imgW="1524368" imgH="431831" progId="">
-                  <p:embed/>
-                  <p:pic>
-                    <p:nvPicPr>
-                      <p:cNvPr id="8" name="Object 5"/>
-                      <p:cNvPicPr>
-                        <a:picLocks noGrp="1" noChangeAspect="1" noChangeArrowheads="1"/>
-                      </p:cNvPicPr>
-                      <p:nvPr/>
-                    </p:nvPicPr>
-                    <p:blipFill>
-                      <a:blip r:embed="rId6">
-                        <a:extLst>
-                          <a:ext uri="{28A0092B-C50C-407E-A947-70E740481C1C}">
-                            <a14:useLocalDpi xmlns:a14="http://schemas.microsoft.com/office/drawing/2010/main" val="0"/>
-                          </a:ext>
-                        </a:extLst>
-                      </a:blip>
-                      <a:srcRect/>
-                      <a:stretch>
-                        <a:fillRect/>
-                      </a:stretch>
-                    </p:blipFill>
-                    <p:spPr bwMode="auto">
-                      <a:xfrm>
-                        <a:off x="4985267" y="5561043"/>
-                        <a:ext cx="3865562" cy="1095375"/>
-                      </a:xfrm>
-                      <a:prstGeom prst="rect">
-                        <a:avLst/>
-                      </a:prstGeom>
-                      <a:noFill/>
-                      <a:ln>
-                        <a:noFill/>
-                      </a:ln>
-                      <a:extLst>
-                        <a:ext uri="{909E8E84-426E-40DD-AFC4-6F175D3DCCD1}">
-                          <a14:hiddenFill xmlns:a14="http://schemas.microsoft.com/office/drawing/2010/main">
-                            <a:solidFill>
-                              <a:srgbClr val="FFFFFF"/>
-                            </a:solidFill>
-                          </a14:hiddenFill>
-                        </a:ext>
-                        <a:ext uri="{91240B29-F687-4F45-9708-019B960494DF}">
-                          <a14:hiddenLine xmlns:a14="http://schemas.microsoft.com/office/drawing/2010/main" w="9525">
-                            <a:solidFill>
-                              <a:schemeClr val="tx1"/>
-                            </a:solidFill>
-                            <a:miter lim="800000"/>
-                            <a:headEnd/>
-                            <a:tailEnd/>
-                          </a14:hiddenLine>
-                        </a:ext>
-                      </a:extLst>
-                    </p:spPr>
-                  </p:pic>
-                </p:oleObj>
-              </mc:Fallback>
-            </mc:AlternateContent>
-          </a:graphicData>
-        </a:graphic>
-      </p:graphicFrame>
       <p:sp>
         <p:nvSpPr>
           <p:cNvPr id="10" name="Rectangle 9"/>
@@ -43906,6 +42993,188 @@
               <a:buNone/>
             </a:pPr>
             <a:endParaRPr lang="en-US" altLang="en-US" sz="2800" dirty="0"/>
+          </a:p>
+        </p:txBody>
+      </p:sp>
+      <p:sp>
+        <p:nvSpPr>
+          <p:cNvPr id="133126" name="TextBox 133125"/>
+          <p:cNvSpPr txBox="1"/>
+          <p:nvPr/>
+        </p:nvSpPr>
+        <p:spPr>
+          <a:xfrm>
+            <a:off x="4881076" y="2434774"/>
+            <a:ext cx="2855913" cy="882650"/>
+          </a:xfrm>
+          <a:prstGeom prst="rect">
+            <a:avLst/>
+          </a:prstGeom>
+          <a:noFill/>
+        </p:spPr>
+        <p:txBody>
+          <a:bodyPr wrap="square" anchor="ctr" lIns="0" rIns="0" tIns="0" bIns="0">
+            <a:spAutoFit/>
+          </a:bodyPr>
+          <a:lstStyle/>
+          <a:p>
+            <a:r>
+              <a:rPr sz="1500">
+                <a:latin typeface="Cambria"/>
+              </a:rPr>
+              <a:t>σ</a:t>
+            </a:r>
+            <a:r>
+              <a:rPr sz="1500" baseline="30000">
+                <a:latin typeface="Cambria"/>
+              </a:rPr>
+              <a:t>2</a:t>
+            </a:r>
+            <a:r>
+              <a:rPr sz="1500">
+                <a:latin typeface="Cambria"/>
+              </a:rPr>
+              <a:t> = Σ</a:t>
+            </a:r>
+            <a:r>
+              <a:rPr sz="1500" baseline="-25000">
+                <a:latin typeface="Cambria"/>
+              </a:rPr>
+              <a:t>i=1</a:t>
+            </a:r>
+            <a:r>
+              <a:rPr sz="1500" baseline="30000">
+                <a:latin typeface="Cambria"/>
+              </a:rPr>
+              <a:t>N</a:t>
+            </a:r>
+            <a:r>
+              <a:rPr sz="1500">
+                <a:latin typeface="Cambria"/>
+              </a:rPr>
+              <a:t> (x</a:t>
+            </a:r>
+            <a:r>
+              <a:rPr sz="1500" baseline="-25000">
+                <a:latin typeface="Cambria"/>
+              </a:rPr>
+              <a:t>i</a:t>
+            </a:r>
+            <a:r>
+              <a:rPr sz="1500">
+                <a:latin typeface="Cambria"/>
+              </a:rPr>
+              <a:t> − μ)</a:t>
+            </a:r>
+            <a:r>
+              <a:rPr sz="1500" baseline="30000">
+                <a:latin typeface="Cambria"/>
+              </a:rPr>
+              <a:t>2</a:t>
+            </a:r>
+            <a:r>
+              <a:rPr sz="1500">
+                <a:latin typeface="Cambria"/>
+              </a:rPr>
+              <a:t> P(x</a:t>
+            </a:r>
+            <a:r>
+              <a:rPr sz="1500" baseline="-25000">
+                <a:latin typeface="Cambria"/>
+              </a:rPr>
+              <a:t>i</a:t>
+            </a:r>
+            <a:r>
+              <a:rPr sz="1500">
+                <a:latin typeface="Cambria"/>
+              </a:rPr>
+              <a:t>)</a:t>
+            </a:r>
+          </a:p>
+        </p:txBody>
+      </p:sp>
+      <p:sp>
+        <p:nvSpPr>
+          <p:cNvPr id="133127" name="TextBox 133126"/>
+          <p:cNvSpPr txBox="1"/>
+          <p:nvPr/>
+        </p:nvSpPr>
+        <p:spPr>
+          <a:xfrm>
+            <a:off x="4985267" y="5561043"/>
+            <a:ext cx="3865562" cy="1095375"/>
+          </a:xfrm>
+          <a:prstGeom prst="rect">
+            <a:avLst/>
+          </a:prstGeom>
+          <a:noFill/>
+        </p:spPr>
+        <p:txBody>
+          <a:bodyPr wrap="square" anchor="ctr" lIns="0" rIns="0" tIns="0" bIns="0">
+            <a:spAutoFit/>
+          </a:bodyPr>
+          <a:lstStyle/>
+          <a:p>
+            <a:r>
+              <a:rPr sz="2100">
+                <a:latin typeface="Cambria"/>
+              </a:rPr>
+              <a:t>E(X) = μ</a:t>
+            </a:r>
+            <a:r>
+              <a:rPr sz="2100" baseline="-25000">
+                <a:latin typeface="Cambria"/>
+              </a:rPr>
+              <a:t>X</a:t>
+            </a:r>
+            <a:r>
+              <a:rPr sz="2100">
+                <a:latin typeface="Cambria"/>
+              </a:rPr>
+              <a:t> = Σ</a:t>
+            </a:r>
+            <a:r>
+              <a:rPr sz="2100" baseline="-25000">
+                <a:latin typeface="Cambria"/>
+              </a:rPr>
+              <a:t>i=1</a:t>
+            </a:r>
+            <a:r>
+              <a:rPr sz="2100" baseline="30000">
+                <a:latin typeface="Cambria"/>
+              </a:rPr>
+              <a:t>N</a:t>
+            </a:r>
+            <a:r>
+              <a:rPr sz="2100">
+                <a:latin typeface="Cambria"/>
+              </a:rPr>
+              <a:t> x</a:t>
+            </a:r>
+            <a:r>
+              <a:rPr sz="2100" baseline="-25000">
+                <a:latin typeface="Cambria"/>
+              </a:rPr>
+              <a:t>i</a:t>
+            </a:r>
+            <a:r>
+              <a:rPr sz="2100">
+                <a:latin typeface="Cambria"/>
+              </a:rPr>
+              <a:t> P(x</a:t>
+            </a:r>
+            <a:r>
+              <a:rPr sz="2100" baseline="-25000">
+                <a:latin typeface="Cambria"/>
+              </a:rPr>
+              <a:t>i</a:t>
+            </a:r>
+            <a:r>
+              <a:rPr sz="2100">
+                <a:latin typeface="Cambria"/>
+              </a:rPr>
+              <a:t>)</a:t>
+            </a:r>
           </a:p>
         </p:txBody>
       </p:sp>

</xml_diff>